<commit_message>
docs: update delivery report and slides
</commit_message>
<xml_diff>
--- a/docs/tech-challenge-3/apresentacao.pptx
+++ b/docs/tech-challenge-3/apresentacao.pptx
@@ -3218,7 +3218,7 @@
                 </a:solidFill>
                 <a:latin typeface="Segoe UI"/>
               </a:rPr>
-              <a:t>De funciona a opera: autenticação na borda, rede fechada e o sistema observável.</a:t>
+              <a:t>Autenticação na borda, rede privada, ambientes segregados e observabilidade.</a:t>
             </a:r>
           </a:p>
         </p:txBody>
@@ -3413,7 +3413,7 @@
                 </a:solidFill>
                 <a:latin typeface="Segoe UI"/>
               </a:rPr>
-              <a:t>Os três dashboards não saem do agente</a:t>
+              <a:t>Dashboards de negócio</a:t>
             </a:r>
           </a:p>
         </p:txBody>
@@ -3452,7 +3452,7 @@
                 </a:solidFill>
                 <a:latin typeface="Segoe UI"/>
               </a:rPr>
-              <a:t>Ele entrega latência e erro HTTP. Não sabe o que é uma ordem de serviço.</a:t>
+              <a:t>Métricas customizadas emitidas pela aplicação, complementares aos dados do APM.</a:t>
             </a:r>
           </a:p>
         </p:txBody>
@@ -3645,7 +3645,7 @@
                 </a:solidFill>
                 <a:latin typeface="Segoe UI"/>
               </a:rPr>
-              <a:t>Emitida no caso de uso, não no controller: descreve evento de negócio, não requisição HTTP.</a:t>
+              <a:t>Emitida no caso de uso, representando o evento de negócio.</a:t>
             </a:r>
           </a:p>
         </p:txBody>
@@ -3838,7 +3838,7 @@
                 </a:solidFill>
                 <a:latin typeface="Segoe UI"/>
               </a:rPr>
-              <a:t>O agregado mede a permanência no estado anterior e enfileira o evento; o adaptador drena no salvar.</a:t>
+              <a:t>O agregado mede a permanência no estado anterior, e o adaptador de persistência publica o evento.</a:t>
             </a:r>
           </a:p>
         </p:txBody>
@@ -4114,7 +4114,7 @@
                 </a:solidFill>
                 <a:latin typeface="Segoe UI"/>
               </a:rPr>
-              <a:t>6 alertas criados por Terraform, nomeados AWS-OficinaAPI-&lt;Amb&gt;-&lt;Recurso&gt;-&lt;Sintoma&gt;-&lt;Severidade&gt; — e cada um com link para um runbook que existe.</a:t>
+              <a:t>6 alertas criados por Terraform, no padrão AWS-OficinaAPI-&lt;Amb&gt;-&lt;Recurso&gt;-&lt;Sintoma&gt;-&lt;Severidade&gt;, cada um com link para o runbook correspondente.</a:t>
             </a:r>
           </a:p>
         </p:txBody>
@@ -4215,7 +4215,7 @@
                 </a:solidFill>
                 <a:latin typeface="Segoe UI"/>
               </a:rPr>
-              <a:t>Documentação versionada junto do código</a:t>
+              <a:t>Documentação arquitetural</a:t>
             </a:r>
           </a:p>
         </p:txBody>
@@ -4254,7 +4254,7 @@
                 </a:solidFill>
                 <a:latin typeface="Segoe UI"/>
               </a:rPr>
-              <a:t>3 RFCs · 11 ADRs · 3 diagramas C4 · 2 de sequência · 1 DER · 6 runbooks</a:t>
+              <a:t>3 RFCs · 14 ADRs · 3 diagramas C4 · 2 de sequência · 1 DER · 6 runbooks</a:t>
             </a:r>
           </a:p>
         </p:txBody>
@@ -4415,7 +4415,7 @@
                 </a:solidFill>
                 <a:latin typeface="Segoe UI"/>
               </a:rPr>
-              <a:t>Propõe a direção e coleta comentários.</a:t>
+              <a:t>Registra a proposta, os comentários dos revisores e sua resolução.</a:t>
             </a:r>
           </a:p>
           <a:p>
@@ -4447,39 +4447,7 @@
                 </a:solidFill>
                 <a:latin typeface="Segoe UI"/>
               </a:rPr>
-              <a:t>Guardamos os comentários dos revisores e a resolução de cada um.</a:t>
-            </a:r>
-          </a:p>
-          <a:p>
-            <a:pPr algn="l">
-              <a:lnSpc>
-                <a:spcPct val="125000"/>
-              </a:lnSpc>
-            </a:pPr>
-            <a:r>
-              <a:rPr sz="1200" b="0" i="0">
-                <a:solidFill>
-                  <a:srgbClr val="5A6270"/>
-                </a:solidFill>
-                <a:latin typeface="Segoe UI"/>
-              </a:rPr>
-              <a:t/>
-            </a:r>
-          </a:p>
-          <a:p>
-            <a:pPr algn="l">
-              <a:lnSpc>
-                <a:spcPct val="125000"/>
-              </a:lnSpc>
-            </a:pPr>
-            <a:r>
-              <a:rPr sz="1200" b="0" i="0">
-                <a:solidFill>
-                  <a:srgbClr val="5A6270"/>
-                </a:solidFill>
-                <a:latin typeface="Segoe UI"/>
-              </a:rPr>
-              <a:t>Nuvem, banco e autenticação.</a:t>
+              <a:t>Temas: nuvem, banco e autenticação.</a:t>
             </a:r>
           </a:p>
         </p:txBody>
@@ -4640,7 +4608,7 @@
                 </a:solidFill>
                 <a:latin typeface="Segoe UI"/>
               </a:rPr>
-              <a:t>Registra o que foi decidido e por quê, com alternativas e consequências.</a:t>
+              <a:t>Registra a decisão, as alternativas e as consequências.</a:t>
             </a:r>
           </a:p>
           <a:p>
@@ -4672,7 +4640,7 @@
                 </a:solidFill>
                 <a:latin typeface="Segoe UI"/>
               </a:rPr>
-              <a:t>Aceita, torna-se imutável: muda-se por nova ADR, não editando.</a:t>
+              <a:t>Após aceita, não é editada; mudanças geram nova ADR.</a:t>
             </a:r>
           </a:p>
         </p:txBody>
@@ -4755,7 +4723,7 @@
                 </a:solidFill>
                 <a:latin typeface="Segoe UI"/>
               </a:rPr>
-              <a:t>HONESTIDADE</a:t>
+              <a:t>OBSERVAÇÃO</a:t>
             </a:r>
           </a:p>
         </p:txBody>
@@ -4794,7 +4762,7 @@
                 </a:solidFill>
                 <a:latin typeface="Segoe UI"/>
               </a:rPr>
-              <a:t>A lacuna</a:t>
+              <a:t>RFC no material</a:t>
             </a:r>
           </a:p>
         </p:txBody>
@@ -4833,7 +4801,7 @@
                 </a:solidFill>
                 <a:latin typeface="Segoe UI"/>
               </a:rPr>
-              <a:t>Nenhuma aula da fase cobre RFC — cobrem ADR, DAS, HLD/LLD e C4.</a:t>
+              <a:t>O material da fase aborda ADR, DAS, HLD/LLD e C4, mas não RFC.</a:t>
             </a:r>
           </a:p>
           <a:p>
@@ -4865,7 +4833,7 @@
                 </a:solidFill>
                 <a:latin typeface="Segoe UI"/>
               </a:rPr>
-              <a:t>Tratamos como extensão consciente, e dissemos isso.</a:t>
+              <a:t>A convenção adotada está documentada.</a:t>
             </a:r>
           </a:p>
         </p:txBody>
@@ -4904,7 +4872,7 @@
                 </a:solidFill>
                 <a:latin typeface="Segoe UI"/>
               </a:rPr>
-              <a:t>A ADR-011, retroativa sobre o HPA, revelou um desencontro real: o HPA pedia 4 réplicas com o node group limitado a 3 nós. Corrigido.</a:t>
+              <a:t>A ADR-011, retroativa, identificou divergência entre o HPA (4 réplicas) e o node group (3 nós), corrigida nesta fase.</a:t>
             </a:r>
           </a:p>
         </p:txBody>
@@ -5122,7 +5090,7 @@
                 </a:solidFill>
                 <a:latin typeface="Segoe UI"/>
               </a:rPr>
-              <a:t>Chamada sem token → 401 no gateway. O log do pod não registra nada.</a:t>
+              <a:t>Chamada sem token → 401 no gateway, sem registro no log do pod.</a:t>
             </a:r>
           </a:p>
         </p:txBody>
@@ -5200,7 +5168,7 @@
                 </a:solidFill>
                 <a:latin typeface="Segoe UI"/>
               </a:rPr>
-              <a:t>POST /auth com CPF → JWT. Claims em jwt.io: sub é o UUID, não o CPF.</a:t>
+              <a:t>POST /auth com CPF → JWT. Claims em jwt.io: sub com o UUID do cliente.</a:t>
             </a:r>
           </a:p>
         </p:txBody>
@@ -5278,7 +5246,7 @@
                 </a:solidFill>
                 <a:latin typeface="Segoe UI"/>
               </a:rPr>
-              <a:t>CPF inválido → 400. Cliente bloqueado → 403, com a MESMA mensagem do 404.</a:t>
+              <a:t>CPF inválido → 400. Cliente bloqueado → 403, com a mesma mensagem do 404.</a:t>
             </a:r>
           </a:p>
         </p:txBody>
@@ -5574,7 +5542,7 @@
                 </a:solidFill>
                 <a:latin typeface="Segoe UI"/>
               </a:rPr>
-              <a:t>Merge do PR → pipeline: testes, Sonar, imagem no ECR. Push direto em main é bloqueado.</a:t>
+              <a:t>Merge do PR na develop → pipeline: testes e imagem no ECR de homologação.</a:t>
             </a:r>
           </a:p>
         </p:txBody>
@@ -5652,7 +5620,7 @@
                 </a:solidFill>
                 <a:latin typeface="Segoe UI"/>
               </a:rPr>
-              <a:t>Deploy automático no EKS, rollout até concluir. Nenhum comando manual.</a:t>
+              <a:t>Deploy automático no EKS de homologação, até a conclusão do rollout.</a:t>
             </a:r>
           </a:p>
         </p:txBody>
@@ -5730,7 +5698,7 @@
                 </a:solidFill>
                 <a:latin typeface="Segoe UI"/>
               </a:rPr>
-              <a:t>k6 gerando carga → dashboard de negócio subindo e o HPA criando réplica.</a:t>
+              <a:t>Carga com k6 → dashboard de negócio e criação de réplica pelo HPA.</a:t>
             </a:r>
           </a:p>
         </p:txBody>
@@ -5808,7 +5776,7 @@
                 </a:solidFill>
                 <a:latin typeface="Segoe UI"/>
               </a:rPr>
-              <a:t>Busca pelo ID da OS do DEMO 1: log estruturado → um clique → trace distribuído.</a:t>
+              <a:t>Busca pelo ID da OS do DEMO 1: log estruturado → trace distribuído.</a:t>
             </a:r>
           </a:p>
         </p:txBody>
@@ -5909,7 +5877,7 @@
                 </a:solidFill>
                 <a:latin typeface="Segoe UI"/>
               </a:rPr>
-              <a:t>O que entregamos</a:t>
+              <a:t>Resultados</a:t>
             </a:r>
           </a:p>
         </p:txBody>
@@ -5948,7 +5916,7 @@
                 </a:solidFill>
                 <a:latin typeface="Segoe UI"/>
               </a:rPr>
-              <a:t>E o que ficou registrado como dívida.</a:t>
+              <a:t>Entregas da fase e débitos técnicos registrados.</a:t>
             </a:r>
           </a:p>
         </p:txBody>
@@ -6109,7 +6077,7 @@
                 </a:solidFill>
                 <a:latin typeface="Segoe UI"/>
               </a:rPr>
-              <a:t>Autenticação fora da aplicação, borda protegida por gateway, rede fechada.</a:t>
+              <a:t>Autenticação fora da aplicação, borda protegida por gateway e rede privada.</a:t>
             </a:r>
           </a:p>
           <a:p>
@@ -6141,7 +6109,7 @@
                 </a:solidFill>
                 <a:latin typeface="Segoe UI"/>
               </a:rPr>
-              <a:t>Quatro esteiras independentes, com um contrato só.</a:t>
+              <a:t>Quatro pipelines com menor privilégio e dois ambientes segregados.</a:t>
             </a:r>
           </a:p>
         </p:txBody>
@@ -6302,7 +6270,7 @@
                 </a:solidFill>
                 <a:latin typeface="Segoe UI"/>
               </a:rPr>
-              <a:t>Métricas que respondem perguntas de negócio.</a:t>
+              <a:t>Métricas de negócio.</a:t>
             </a:r>
           </a:p>
           <a:p>
@@ -6334,7 +6302,7 @@
                 </a:solidFill>
                 <a:latin typeface="Segoe UI"/>
               </a:rPr>
-              <a:t>Logs que abrem o trace com um clique.</a:t>
+              <a:t>Logs estruturados correlacionados aos traces.</a:t>
             </a:r>
           </a:p>
           <a:p>
@@ -6366,7 +6334,7 @@
                 </a:solidFill>
                 <a:latin typeface="Segoe UI"/>
               </a:rPr>
-              <a:t>Alertas que apontam para procedimento, não para gráfico.</a:t>
+              <a:t>Alertas associados a runbooks.</a:t>
             </a:r>
           </a:p>
         </p:txBody>
@@ -6449,7 +6417,7 @@
                 </a:solidFill>
                 <a:latin typeface="Segoe UI"/>
               </a:rPr>
-              <a:t>DECLARADO</a:t>
+              <a:t>REGISTRADO</a:t>
             </a:r>
           </a:p>
         </p:txBody>
@@ -6488,7 +6456,7 @@
                 </a:solidFill>
                 <a:latin typeface="Segoe UI"/>
               </a:rPr>
-              <a:t>8 débitos técnicos</a:t>
+              <a:t>9 débitos técnicos</a:t>
             </a:r>
           </a:p>
         </p:txBody>
@@ -6527,7 +6495,7 @@
                 </a:solidFill>
                 <a:latin typeface="Segoe UI"/>
               </a:rPr>
-              <a:t>O que mais preocupa está dito: autenticar só por CPF é fraco.</a:t>
+              <a:t>Autenticação só por CPF atende ao enunciado, com mitigações aplicadas.</a:t>
             </a:r>
           </a:p>
           <a:p>
@@ -6559,7 +6527,7 @@
                 </a:solidFill>
                 <a:latin typeface="Segoe UI"/>
               </a:rPr>
-              <a:t>Entregamos porque foi o que se pediu — com as mitigações que couberam e a ressalva registrada.</a:t>
+              <a:t>O segundo fator fica planejado para uma próxima etapa, fora do escopo desta entrega.</a:t>
             </a:r>
           </a:p>
         </p:txBody>
@@ -6699,7 +6667,7 @@
                 </a:solidFill>
                 <a:latin typeface="Segoe UI"/>
               </a:rPr>
-              <a:t>De onde partimos</a:t>
+              <a:t>Situação ao final da Fase 2</a:t>
             </a:r>
           </a:p>
         </p:txBody>
@@ -6738,7 +6706,7 @@
                 </a:solidFill>
                 <a:latin typeface="Segoe UI"/>
               </a:rPr>
-              <a:t>Dois dos cinco requisitos de infraestrutura desta fase já estavam atendidos pela Fase 2.</a:t>
+              <a:t>Três dos cinco requisitos de infraestrutura desta fase já estavam atendidos.</a:t>
             </a:r>
           </a:p>
         </p:txBody>
@@ -7124,7 +7092,7 @@
                 </a:solidFill>
                 <a:latin typeface="Segoe UI"/>
               </a:rPr>
-              <a:t>Build, testes, SonarCloud, OWASP e deploy automático no cluster.</a:t>
+              <a:t>Build, testes, SonarCloud e deploy automático no cluster.</a:t>
             </a:r>
           </a:p>
           <a:p>
@@ -7156,7 +7124,7 @@
                 </a:solidFill>
                 <a:latin typeface="Segoe UI"/>
               </a:rPr>
-              <a:t>OIDC para a AWS, sem chave de longa duração.</a:t>
+              <a:t>OIDC para a AWS, com uma única role de administrador.</a:t>
             </a:r>
           </a:p>
         </p:txBody>
@@ -7239,7 +7207,7 @@
                 </a:solidFill>
                 <a:latin typeface="Segoe UI"/>
               </a:rPr>
-              <a:t>FALTAVA</a:t>
+              <a:t>PENDENTE</a:t>
             </a:r>
           </a:p>
         </p:txBody>
@@ -7317,7 +7285,7 @@
                 </a:solidFill>
                 <a:latin typeface="Segoe UI"/>
               </a:rPr>
-              <a:t>Sem API Gateway — Spring Security era a única barreira.</a:t>
+              <a:t>Sem API Gateway: a proteção era feita apenas pelo Spring Security.</a:t>
             </a:r>
           </a:p>
           <a:p>
@@ -7349,7 +7317,7 @@
                 </a:solidFill>
                 <a:latin typeface="Segoe UI"/>
               </a:rPr>
-              <a:t>O monolito emitia o próprio token, com um usuário admin em memória.</a:t>
+              <a:t>A aplicação emitia o próprio token, com um usuário administrador em memória.</a:t>
             </a:r>
           </a:p>
         </p:txBody>
@@ -7388,7 +7356,7 @@
                 </a:solidFill>
                 <a:latin typeface="Segoe UI"/>
               </a:rPr>
-              <a:t>O trabalho real ficou em três frentes: autenticação, segregação de repositórios e observabilidade.</a:t>
+              <a:t>A implementação concentrou-se em autenticação, segregação de repositórios e observabilidade.</a:t>
             </a:r>
           </a:p>
         </p:txBody>
@@ -7489,7 +7457,7 @@
                 </a:solidFill>
                 <a:latin typeface="Segoe UI"/>
               </a:rPr>
-              <a:t>O que esta fase exige</a:t>
+              <a:t>Requisitos da Fase 3</a:t>
             </a:r>
           </a:p>
         </p:txBody>
@@ -7528,7 +7496,7 @@
                 </a:solidFill>
                 <a:latin typeface="Segoe UI"/>
               </a:rPr>
-              <a:t>Cinco blocos. Nenhum adiciona funcionalidade de negócio — todos adicionam capacidade de operar.</a:t>
+              <a:t>Os requisitos tratam de capacidade operacional e não acrescentam funcionalidades de negócio.</a:t>
             </a:r>
           </a:p>
         </p:txBody>
@@ -8177,7 +8145,7 @@
                 </a:solidFill>
                 <a:latin typeface="Segoe UI"/>
               </a:rPr>
-              <a:t>O fio que costura os cinco: sair de "funciona" para "opera".</a:t>
+              <a:t>Foco em segurança, operação e visibilidade do sistema.</a:t>
             </a:r>
           </a:p>
         </p:txBody>
@@ -8278,7 +8246,7 @@
                 </a:solidFill>
                 <a:latin typeface="Segoe UI"/>
               </a:rPr>
-              <a:t>A aplicação deixou de emitir tokens</a:t>
+              <a:t>Emissão de tokens na função serverless</a:t>
             </a:r>
           </a:p>
         </p:txBody>
@@ -8317,7 +8285,7 @@
                 </a:solidFill>
                 <a:latin typeface="Segoe UI"/>
               </a:rPr>
-              <a:t>A decisão mais estrutural da fase — e a que mais mexeu no código existente.</a:t>
+              <a:t>Principal alteração na aplicação nesta fase.</a:t>
             </a:r>
           </a:p>
         </p:txBody>
@@ -8538,7 +8506,7 @@
                 </a:solidFill>
                 <a:latin typeface="Segoe UI"/>
               </a:rPr>
-              <a:t>Do monolito</a:t>
+              <a:t>Da aplicação</a:t>
             </a:r>
           </a:p>
         </p:txBody>
@@ -8692,7 +8660,7 @@
                 </a:solidFill>
                 <a:latin typeface="Segoe UI"/>
               </a:rPr>
-              <a:t>GANHO</a:t>
+              <a:t>MOTIVAÇÃO</a:t>
             </a:r>
           </a:p>
         </p:txBody>
@@ -8917,7 +8885,7 @@
                 </a:solidFill>
                 <a:latin typeface="Segoe UI"/>
               </a:rPr>
-              <a:t>REGISTRADO</a:t>
+              <a:t>CONSEQUÊNCIAS</a:t>
             </a:r>
           </a:p>
         </p:txBody>
@@ -8956,7 +8924,7 @@
                 </a:solidFill>
                 <a:latin typeface="Segoe UI"/>
               </a:rPr>
-              <a:t>O que se perdeu</a:t>
+              <a:t>Sessão de 15 minutos</a:t>
             </a:r>
           </a:p>
         </p:txBody>
@@ -8995,7 +8963,7 @@
                 </a:solidFill>
                 <a:latin typeface="Segoe UI"/>
               </a:rPr>
-              <a:t>Não há mais refresh token — o cliente reautentica com o CPF a cada 15 minutos.</a:t>
+              <a:t>Sem refresh token: o cliente se autentica novamente com o CPF quando o token expira.</a:t>
             </a:r>
           </a:p>
           <a:p>
@@ -9027,7 +8995,7 @@
                 </a:solidFill>
                 <a:latin typeface="Segoe UI"/>
               </a:rPr>
-              <a:t>E o sub do token é o UUID, nunca o CPF.</a:t>
+              <a:t>O sub do token é o UUID do cliente, e não o CPF.</a:t>
             </a:r>
           </a:p>
         </p:txBody>
@@ -9128,7 +9096,7 @@
                 </a:solidFill>
                 <a:latin typeface="Segoe UI"/>
               </a:rPr>
-              <a:t>O gateway é a borda</a:t>
+              <a:t>API Gateway</a:t>
             </a:r>
           </a:p>
         </p:txBody>
@@ -9167,7 +9135,7 @@
                 </a:solidFill>
                 <a:latin typeface="Segoe UI"/>
               </a:rPr>
-              <a:t>Requisição sem token válido é rejeitada antes de consumir qualquer recurso do cluster.</a:t>
+              <a:t>Requisições sem token válido são rejeitadas antes de chegar ao cluster.</a:t>
             </a:r>
           </a:p>
         </p:txBody>
@@ -9360,7 +9328,7 @@
                 </a:solidFill>
                 <a:latin typeface="Segoe UI"/>
               </a:rPr>
-              <a:t>A aplicação valida de novo — defesa em profundidade.</a:t>
+              <a:t>Funcionário acessa a gestão; cliente, só as próprias OS e veículos.</a:t>
             </a:r>
           </a:p>
         </p:txBody>
@@ -9443,7 +9411,7 @@
                 </a:solidFill>
                 <a:latin typeface="Segoe UI"/>
               </a:rPr>
-              <a:t>ABERTO</a:t>
+              <a:t>SEM CPF</a:t>
             </a:r>
           </a:p>
         </p:txBody>
@@ -9482,7 +9450,7 @@
                 </a:solidFill>
                 <a:latin typeface="Segoe UI"/>
               </a:rPr>
-              <a:t>Por decisão</a:t>
+              <a:t>Rotas de terceiros</a:t>
             </a:r>
           </a:p>
         </p:txBody>
@@ -9553,7 +9521,7 @@
                 </a:solidFill>
                 <a:latin typeface="Segoe UI"/>
               </a:rPr>
-              <a:t>Aprovação externa de orçamento: quem chama é sistema de terceiro, com token de uso único. Submetê-las ao CPF quebraria a integração.</a:t>
+              <a:t>Aprovação externa de orçamento, chamada por sistema de terceiro com token de uso único.</a:t>
             </a:r>
           </a:p>
         </p:txBody>
@@ -9636,7 +9604,7 @@
                 </a:solidFill>
                 <a:latin typeface="Segoe UI"/>
               </a:rPr>
-              <a:t>POR QUÊ</a:t>
+              <a:t>ESCOLHA</a:t>
             </a:r>
           </a:p>
         </p:txBody>
@@ -9675,7 +9643,7 @@
                 </a:solidFill>
                 <a:latin typeface="Segoe UI"/>
               </a:rPr>
-              <a:t>Authorizer próprio</a:t>
+              <a:t>Lambda authorizer</a:t>
             </a:r>
           </a:p>
         </p:txBody>
@@ -9746,7 +9714,7 @@
                 </a:solidFill>
                 <a:latin typeface="Segoe UI"/>
               </a:rPr>
-              <a:t>Ele não valida HMAC — não há chave pública quando a assinatura é simétrica.</a:t>
+              <a:t>Ele não valida HMAC, pois a assinatura simétrica não possui chave pública.</a:t>
             </a:r>
           </a:p>
         </p:txBody>
@@ -9785,7 +9753,7 @@
                 </a:solidFill>
                 <a:latin typeface="Segoe UI"/>
               </a:rPr>
-              <a:t>Está no diagrama de sequência e na especificação: rota aberta aqui é decisão, não esquecimento.</a:t>
+              <a:t>Decisão registrada no diagrama de sequência e na especificação do gateway.</a:t>
             </a:r>
           </a:p>
         </p:txBody>
@@ -9886,7 +9854,7 @@
                 </a:solidFill>
                 <a:latin typeface="Segoe UI"/>
               </a:rPr>
-              <a:t>Quatro repositórios, um contrato</a:t>
+              <a:t>Repositórios e ambientes</a:t>
             </a:r>
           </a:p>
         </p:txBody>
@@ -9925,7 +9893,7 @@
                 </a:solidFill>
                 <a:latin typeface="Segoe UI"/>
               </a:rPr>
-              <a:t>O monorepo virou quatro esteiras independentes — e o acoplamento entre elas é um só.</a:t>
+              <a:t>Quatro repositórios com pipelines próprios, integrados pelo SSM Parameter Store.</a:t>
             </a:r>
           </a:p>
         </p:txBody>
@@ -10008,7 +9976,7 @@
                 </a:solidFill>
                 <a:latin typeface="Segoe UI"/>
               </a:rPr>
-              <a:t>oficina-api</a:t>
+              <a:t>tech-challenge-1</a:t>
             </a:r>
           </a:p>
         </p:txBody>
@@ -10047,7 +10015,7 @@
                 </a:solidFill>
                 <a:latin typeface="Segoe UI"/>
               </a:rPr>
-              <a:t>Spring Boot · histórico das 3 fases preservado</a:t>
+              <a:t>oficina-api · Spring Boot · histórico das 3 fases</a:t>
             </a:r>
           </a:p>
         </p:txBody>
@@ -10496,7 +10464,7 @@
                 </a:solidFill>
                 <a:latin typeface="Segoe UI"/>
               </a:rPr>
-              <a:t>O CONTRATO: SSM PARAMETER STORE</a:t>
+              <a:t>INTEGRAÇÃO: SSM PARAMETER STORE</a:t>
             </a:r>
           </a:p>
         </p:txBody>
@@ -10535,7 +10503,7 @@
                 </a:solidFill>
                 <a:latin typeface="Segoe UI"/>
               </a:rPr>
-              <a:t>Cada repositório publica seus outputs sob /oficina/&lt;ambiente&gt;/ e consome os dos outros por data source — nunca por terraform_remote_state, para que nenhum precise de permissão no state alheio.</a:t>
+              <a:t>Cada repositório publica seus outputs sob /oficina/&lt;ambiente&gt;/ e consome os dos demais por data source, sem terraform_remote_state, de modo que nenhum precise de permissão sobre o state de outro.</a:t>
             </a:r>
           </a:p>
           <a:p>
@@ -10567,7 +10535,7 @@
                 </a:solidFill>
                 <a:latin typeface="Segoe UI"/>
               </a:rPr>
-              <a:t>main protegida · merge só por PR · develop → homologação · main → produção · OIDC nos quatro</a:t>
+              <a:t>develop → homologação · main → produção com aprovação · cada ambiente com VPC, cluster, banco, state e segredos próprios · uma role por repositório, com menor privilégio</a:t>
             </a:r>
           </a:p>
         </p:txBody>
@@ -10668,7 +10636,7 @@
                 </a:solidFill>
                 <a:latin typeface="Segoe UI"/>
               </a:rPr>
-              <a:t>A rede fechou — e a conta surpreendeu</a:t>
+              <a:t>Rede privada e acesso à internet</a:t>
             </a:r>
           </a:p>
         </p:txBody>
@@ -10707,7 +10675,7 @@
                 </a:solidFill>
                 <a:latin typeface="Segoe UI"/>
               </a:rPr>
-              <a:t>Nós e banco saíram das subnets públicas. Restava escolher como dar saída de internet.</a:t>
+              <a:t>Nós e banco migrados para subnets privadas. Opções avaliadas para a saída de internet:</a:t>
             </a:r>
           </a:p>
         </p:txBody>
@@ -11229,7 +11197,7 @@
                 </a:solidFill>
                 <a:latin typeface="Segoe UI"/>
               </a:rPr>
-              <a:t>Endpoint de interface é cobrado por endpoint E por zona de disponibilidade — sai mais caro que o NAT Gateway. E não resolveria: a telemetria do New Relic vai para endpoint público.</a:t>
+              <a:t>Interface endpoints são cobrados por endpoint e por zona de disponibilidade e não atendem ao endpoint público do New Relic.</a:t>
             </a:r>
           </a:p>
           <a:p>
@@ -11245,7 +11213,7 @@
                 </a:solidFill>
                 <a:latin typeface="Segoe UI"/>
               </a:rPr>
-              <a:t>Bônus: em subnet privada os nós perdem o IPv4 público, cobrado desde fev/2024 — US$ 7,30/mês que estavam sendo gastos à toa.</a:t>
+              <a:t>Em subnet privada, os nós deixam de usar IPv4 público, cobrado desde fev/2024 (US$ 7,30/mês).</a:t>
             </a:r>
           </a:p>
         </p:txBody>
@@ -11346,7 +11314,7 @@
                 </a:solidFill>
                 <a:latin typeface="Segoe UI"/>
               </a:rPr>
-              <a:t>O banco: justificar, não trocar</a:t>
+              <a:t>Banco de dados</a:t>
             </a:r>
           </a:p>
         </p:txBody>
@@ -11385,7 +11353,7 @@
                 </a:solidFill>
                 <a:latin typeface="Segoe UI"/>
               </a:rPr>
-              <a:t>O enunciado pede justificativa formal da escolha. A nossa é de continuidade — e foi avaliada.</a:t>
+              <a:t>PostgreSQL 16 em RDS mantido, com alternativas avaliadas na RFC-002.</a:t>
             </a:r>
           </a:p>
         </p:txBody>
@@ -11578,7 +11546,7 @@
                 </a:solidFill>
                 <a:latin typeface="Segoe UI"/>
               </a:rPr>
-              <a:t>Exigiria desnormalizar e reescrever a persistência inteira, sem ganho para a carga real.</a:t>
+              <a:t>Exigiria desnormalizar e reescrever a camada de persistência.</a:t>
             </a:r>
           </a:p>
         </p:txBody>
@@ -11739,7 +11707,7 @@
                 </a:solidFill>
                 <a:latin typeface="Segoe UI"/>
               </a:rPr>
-              <a:t>Compatível com PostgreSQL, escala a zero.</a:t>
+              <a:t>Compatível com PostgreSQL, com escala automática.</a:t>
             </a:r>
           </a:p>
           <a:p>
@@ -11771,7 +11739,7 @@
                 </a:solidFill>
                 <a:latin typeface="Segoe UI"/>
               </a:rPr>
-              <a:t>A capacidade mínima custa mais que a instância que já usamos.</a:t>
+              <a:t>A capacidade mínima custa mais que a instância utilizada.</a:t>
             </a:r>
           </a:p>
         </p:txBody>
@@ -11932,7 +11900,7 @@
                 </a:solidFill>
                 <a:latin typeface="Segoe UI"/>
               </a:rPr>
-              <a:t>Domínio relacional: integridade em 5 tabelas e junção em toda consulta de OS.</a:t>
+              <a:t>Domínio relacional: integridade referencial em 5 tabelas e junções nas consultas de OS.</a:t>
             </a:r>
           </a:p>
           <a:p>
@@ -12047,7 +12015,7 @@
                 </a:solidFill>
                 <a:latin typeface="Segoe UI"/>
               </a:rPr>
-              <a:t>Ajustes cirúrgicos:  V6 → clientes.status (a Lambda precisa consultá-lo) + 2 índices   ·   V7 → data_ultima_transicao (sem ela não há como medir permanência por status)</a:t>
+              <a:t>Ajustes no modelo:  V6 → clientes.status, consultado pela Lambda, e 2 índices   ·   V7 → data_ultima_transicao, para medir a permanência por status</a:t>
             </a:r>
           </a:p>
         </p:txBody>
@@ -12148,7 +12116,7 @@
                 </a:solidFill>
                 <a:latin typeface="Segoe UI"/>
               </a:rPr>
-              <a:t>Observabilidade: os cinco sinais</a:t>
+              <a:t>Observabilidade</a:t>
             </a:r>
           </a:p>
         </p:txBody>
@@ -12187,7 +12155,7 @@
                 </a:solidFill>
                 <a:latin typeface="Segoe UI"/>
               </a:rPr>
-              <a:t>New Relic, escolhido porque o free tier é perpétuo — o do Datadog é trial de 14 dias.</a:t>
+              <a:t>New Relic: plano gratuito permanente, enquanto o Datadog oferece avaliação de 14 dias.</a:t>
             </a:r>
           </a:p>
         </p:txBody>
@@ -12836,7 +12804,7 @@
                 </a:solidFill>
                 <a:latin typeface="Segoe UI"/>
               </a:rPr>
-              <a:t>Detalhe que economiza metade da cota: o forwarding de log pelo agente fica DESLIGADO — quem envia é o Fluent Bit. Ligar os dois envia cada linha duas vezes.</a:t>
+              <a:t>Encaminhamento de logs pelo agente desativado: o envio é feito pelo Fluent Bit, evitando linhas duplicadas.</a:t>
             </a:r>
           </a:p>
         </p:txBody>

</xml_diff>

<commit_message>
docs: present implementation before happy path demo
</commit_message>
<xml_diff>
--- a/docs/tech-challenge-3/apresentacao.pptx
+++ b/docs/tech-challenge-3/apresentacao.pptx
@@ -4910,7 +4910,7 @@
             <a:avLst/>
           </a:prstGeom>
           <a:solidFill>
-            <a:srgbClr val="141B2D"/>
+            <a:srgbClr val="FAFAF7"/>
           </a:solidFill>
           <a:ln>
             <a:noFill/>
@@ -4947,8 +4947,8 @@
         </p:nvSpPr>
         <p:spPr>
           <a:xfrm>
-            <a:off x="777240" y="1371600"/>
-            <a:ext cx="10637215" cy="822960"/>
+            <a:off x="777240" y="502920"/>
+            <a:ext cx="10637215" cy="640080"/>
           </a:xfrm>
           <a:prstGeom prst="rect">
             <a:avLst/>
@@ -4967,13 +4967,13 @@
               </a:lnSpc>
             </a:pPr>
             <a:r>
-              <a:rPr sz="5400" b="1" i="0">
-                <a:solidFill>
-                  <a:srgbClr val="FAFAF7"/>
-                </a:solidFill>
-                <a:latin typeface="Segoe UI"/>
-              </a:rPr>
-              <a:t>DEMO 1</a:t>
+              <a:rPr sz="3000" b="1" i="0">
+                <a:solidFill>
+                  <a:srgbClr val="141B2D"/>
+                </a:solidFill>
+                <a:latin typeface="Segoe UI"/>
+              </a:rPr>
+              <a:t>Resultados</a:t>
             </a:r>
           </a:p>
         </p:txBody>
@@ -4986,7 +4986,7 @@
         </p:nvSpPr>
         <p:spPr>
           <a:xfrm>
-            <a:off x="777240" y="2331720"/>
+            <a:off x="777240" y="1170432"/>
             <a:ext cx="10637215" cy="457200"/>
           </a:xfrm>
           <a:prstGeom prst="rect">
@@ -5006,27 +5006,71 @@
               </a:lnSpc>
             </a:pPr>
             <a:r>
-              <a:rPr sz="2200" b="0" i="0">
-                <a:solidFill>
-                  <a:srgbClr val="B9C4D4"/>
-                </a:solidFill>
-                <a:latin typeface="Segoe UI"/>
-              </a:rPr>
-              <a:t>Autenticação por CPF e APIs protegidas</a:t>
-            </a:r>
-          </a:p>
-        </p:txBody>
-      </p:sp>
-      <p:sp>
-        <p:nvSpPr>
-          <p:cNvPr id="5" name="TextBox 4"/>
-          <p:cNvSpPr txBox="1"/>
-          <p:nvPr/>
-        </p:nvSpPr>
-        <p:spPr>
-          <a:xfrm>
-            <a:off x="777240" y="3291840"/>
-            <a:ext cx="457200" cy="365760"/>
+              <a:rPr sz="1400" b="0" i="0">
+                <a:solidFill>
+                  <a:srgbClr val="5A6270"/>
+                </a:solidFill>
+                <a:latin typeface="Segoe UI"/>
+              </a:rPr>
+              <a:t>O que foi entregue nesta fase.</a:t>
+            </a:r>
+          </a:p>
+        </p:txBody>
+      </p:sp>
+      <p:sp>
+        <p:nvSpPr>
+          <p:cNvPr id="5" name="Rectangle 4"/>
+          <p:cNvSpPr/>
+          <p:nvPr/>
+        </p:nvSpPr>
+        <p:spPr>
+          <a:xfrm>
+            <a:off x="777240" y="1965960"/>
+            <a:ext cx="3375050" cy="3291840"/>
+          </a:xfrm>
+          <a:prstGeom prst="rect">
+            <a:avLst/>
+          </a:prstGeom>
+          <a:solidFill>
+            <a:srgbClr val="E9EDF2"/>
+          </a:solidFill>
+          <a:ln>
+            <a:noFill/>
+          </a:ln>
+          <a:effectLst/>
+        </p:spPr>
+        <p:style>
+          <a:lnRef idx="1">
+            <a:schemeClr val="accent1"/>
+          </a:lnRef>
+          <a:fillRef idx="3">
+            <a:schemeClr val="accent1"/>
+          </a:fillRef>
+          <a:effectRef idx="2">
+            <a:schemeClr val="accent1"/>
+          </a:effectRef>
+          <a:fontRef idx="minor">
+            <a:schemeClr val="lt1"/>
+          </a:fontRef>
+        </p:style>
+        <p:txBody>
+          <a:bodyPr rtlCol="0" anchor="ctr"/>
+          <a:lstStyle/>
+          <a:p>
+            <a:pPr algn="ctr"/>
+          </a:p>
+        </p:txBody>
+      </p:sp>
+      <p:sp>
+        <p:nvSpPr>
+          <p:cNvPr id="6" name="TextBox 5"/>
+          <p:cNvSpPr txBox="1"/>
+          <p:nvPr/>
+        </p:nvSpPr>
+        <p:spPr>
+          <a:xfrm>
+            <a:off x="1005840" y="2185416"/>
+            <a:ext cx="2917850" cy="274320"/>
           </a:xfrm>
           <a:prstGeom prst="rect">
             <a:avLst/>
@@ -5045,27 +5089,27 @@
               </a:lnSpc>
             </a:pPr>
             <a:r>
-              <a:rPr sz="2000" b="1" i="0">
-                <a:solidFill>
-                  <a:srgbClr val="6F9DD9"/>
-                </a:solidFill>
-                <a:latin typeface="Segoe UI"/>
-              </a:rPr>
-              <a:t>1</a:t>
-            </a:r>
-          </a:p>
-        </p:txBody>
-      </p:sp>
-      <p:sp>
-        <p:nvSpPr>
-          <p:cNvPr id="6" name="TextBox 5"/>
-          <p:cNvSpPr txBox="1"/>
-          <p:nvPr/>
-        </p:nvSpPr>
-        <p:spPr>
-          <a:xfrm>
-            <a:off x="1417320" y="3328416"/>
-            <a:ext cx="9814255" cy="365760"/>
+              <a:rPr sz="1000" b="1" i="0">
+                <a:solidFill>
+                  <a:srgbClr val="2B5C9B"/>
+                </a:solidFill>
+                <a:latin typeface="Segoe UI"/>
+              </a:rPr>
+              <a:t>ENTREGUE</a:t>
+            </a:r>
+          </a:p>
+        </p:txBody>
+      </p:sp>
+      <p:sp>
+        <p:nvSpPr>
+          <p:cNvPr id="7" name="TextBox 6"/>
+          <p:cNvSpPr txBox="1"/>
+          <p:nvPr/>
+        </p:nvSpPr>
+        <p:spPr>
+          <a:xfrm>
+            <a:off x="1005840" y="2532888"/>
+            <a:ext cx="2917850" cy="548640"/>
           </a:xfrm>
           <a:prstGeom prst="rect">
             <a:avLst/>
@@ -5084,27 +5128,142 @@
               </a:lnSpc>
             </a:pPr>
             <a:r>
-              <a:rPr sz="1500" b="0" i="0">
-                <a:solidFill>
-                  <a:srgbClr val="FAFAF7"/>
-                </a:solidFill>
-                <a:latin typeface="Segoe UI"/>
-              </a:rPr>
-              <a:t>Chamada sem token → 401 no gateway, sem registro no log do pod.</a:t>
-            </a:r>
-          </a:p>
-        </p:txBody>
-      </p:sp>
-      <p:sp>
-        <p:nvSpPr>
-          <p:cNvPr id="7" name="TextBox 6"/>
-          <p:cNvSpPr txBox="1"/>
-          <p:nvPr/>
-        </p:nvSpPr>
-        <p:spPr>
-          <a:xfrm>
-            <a:off x="777240" y="3950208"/>
-            <a:ext cx="457200" cy="365760"/>
+              <a:rPr sz="1600" b="1" i="0">
+                <a:solidFill>
+                  <a:srgbClr val="141B2D"/>
+                </a:solidFill>
+                <a:latin typeface="Segoe UI"/>
+              </a:rPr>
+              <a:t>Operação</a:t>
+            </a:r>
+          </a:p>
+        </p:txBody>
+      </p:sp>
+      <p:sp>
+        <p:nvSpPr>
+          <p:cNvPr id="8" name="TextBox 7"/>
+          <p:cNvSpPr txBox="1"/>
+          <p:nvPr/>
+        </p:nvSpPr>
+        <p:spPr>
+          <a:xfrm>
+            <a:off x="1005840" y="3200400"/>
+            <a:ext cx="2917850" cy="1828800"/>
+          </a:xfrm>
+          <a:prstGeom prst="rect">
+            <a:avLst/>
+          </a:prstGeom>
+          <a:noFill/>
+        </p:spPr>
+        <p:txBody>
+          <a:bodyPr wrap="square" anchor="t" lIns="0" rIns="0" tIns="0" bIns="0">
+            <a:spAutoFit/>
+          </a:bodyPr>
+          <a:lstStyle/>
+          <a:p>
+            <a:pPr algn="l">
+              <a:lnSpc>
+                <a:spcPct val="125000"/>
+              </a:lnSpc>
+            </a:pPr>
+            <a:r>
+              <a:rPr sz="1200" b="0" i="0">
+                <a:solidFill>
+                  <a:srgbClr val="5A6270"/>
+                </a:solidFill>
+                <a:latin typeface="Segoe UI"/>
+              </a:rPr>
+              <a:t>Autenticação por CPF fora da aplicação, com papéis de cliente e funcionário.</a:t>
+            </a:r>
+          </a:p>
+          <a:p>
+            <a:pPr algn="l">
+              <a:lnSpc>
+                <a:spcPct val="125000"/>
+              </a:lnSpc>
+            </a:pPr>
+            <a:r>
+              <a:rPr sz="1200" b="0" i="0">
+                <a:solidFill>
+                  <a:srgbClr val="5A6270"/>
+                </a:solidFill>
+                <a:latin typeface="Segoe UI"/>
+              </a:rPr>
+              <a:t/>
+            </a:r>
+          </a:p>
+          <a:p>
+            <a:pPr algn="l">
+              <a:lnSpc>
+                <a:spcPct val="125000"/>
+              </a:lnSpc>
+            </a:pPr>
+            <a:r>
+              <a:rPr sz="1200" b="0" i="0">
+                <a:solidFill>
+                  <a:srgbClr val="5A6270"/>
+                </a:solidFill>
+                <a:latin typeface="Segoe UI"/>
+              </a:rPr>
+              <a:t>Gateway na borda, rede privada e dois ambientes segregados.</a:t>
+            </a:r>
+          </a:p>
+        </p:txBody>
+      </p:sp>
+      <p:sp>
+        <p:nvSpPr>
+          <p:cNvPr id="9" name="Rectangle 8"/>
+          <p:cNvSpPr/>
+          <p:nvPr/>
+        </p:nvSpPr>
+        <p:spPr>
+          <a:xfrm>
+            <a:off x="4408322" y="1965960"/>
+            <a:ext cx="3375050" cy="3291840"/>
+          </a:xfrm>
+          <a:prstGeom prst="rect">
+            <a:avLst/>
+          </a:prstGeom>
+          <a:solidFill>
+            <a:srgbClr val="E9EDF2"/>
+          </a:solidFill>
+          <a:ln>
+            <a:noFill/>
+          </a:ln>
+          <a:effectLst/>
+        </p:spPr>
+        <p:style>
+          <a:lnRef idx="1">
+            <a:schemeClr val="accent1"/>
+          </a:lnRef>
+          <a:fillRef idx="3">
+            <a:schemeClr val="accent1"/>
+          </a:fillRef>
+          <a:effectRef idx="2">
+            <a:schemeClr val="accent1"/>
+          </a:effectRef>
+          <a:fontRef idx="minor">
+            <a:schemeClr val="lt1"/>
+          </a:fontRef>
+        </p:style>
+        <p:txBody>
+          <a:bodyPr rtlCol="0" anchor="ctr"/>
+          <a:lstStyle/>
+          <a:p>
+            <a:pPr algn="ctr"/>
+          </a:p>
+        </p:txBody>
+      </p:sp>
+      <p:sp>
+        <p:nvSpPr>
+          <p:cNvPr id="10" name="TextBox 9"/>
+          <p:cNvSpPr txBox="1"/>
+          <p:nvPr/>
+        </p:nvSpPr>
+        <p:spPr>
+          <a:xfrm>
+            <a:off x="4636922" y="2185416"/>
+            <a:ext cx="2917850" cy="274320"/>
           </a:xfrm>
           <a:prstGeom prst="rect">
             <a:avLst/>
@@ -5123,27 +5282,27 @@
               </a:lnSpc>
             </a:pPr>
             <a:r>
-              <a:rPr sz="2000" b="1" i="0">
-                <a:solidFill>
-                  <a:srgbClr val="6F9DD9"/>
-                </a:solidFill>
-                <a:latin typeface="Segoe UI"/>
-              </a:rPr>
-              <a:t>2</a:t>
-            </a:r>
-          </a:p>
-        </p:txBody>
-      </p:sp>
-      <p:sp>
-        <p:nvSpPr>
-          <p:cNvPr id="8" name="TextBox 7"/>
-          <p:cNvSpPr txBox="1"/>
-          <p:nvPr/>
-        </p:nvSpPr>
-        <p:spPr>
-          <a:xfrm>
-            <a:off x="1417320" y="3986784"/>
-            <a:ext cx="9814255" cy="365760"/>
+              <a:rPr sz="1000" b="1" i="0">
+                <a:solidFill>
+                  <a:srgbClr val="2B5C9B"/>
+                </a:solidFill>
+                <a:latin typeface="Segoe UI"/>
+              </a:rPr>
+              <a:t>ENTREGUE</a:t>
+            </a:r>
+          </a:p>
+        </p:txBody>
+      </p:sp>
+      <p:sp>
+        <p:nvSpPr>
+          <p:cNvPr id="11" name="TextBox 10"/>
+          <p:cNvSpPr txBox="1"/>
+          <p:nvPr/>
+        </p:nvSpPr>
+        <p:spPr>
+          <a:xfrm>
+            <a:off x="4636922" y="2532888"/>
+            <a:ext cx="2917850" cy="548640"/>
           </a:xfrm>
           <a:prstGeom prst="rect">
             <a:avLst/>
@@ -5162,27 +5321,174 @@
               </a:lnSpc>
             </a:pPr>
             <a:r>
-              <a:rPr sz="1500" b="0" i="0">
-                <a:solidFill>
-                  <a:srgbClr val="FAFAF7"/>
-                </a:solidFill>
-                <a:latin typeface="Segoe UI"/>
-              </a:rPr>
-              <a:t>POST /auth com CPF → JWT. Claims em jwt.io: sub com o UUID do cliente.</a:t>
-            </a:r>
-          </a:p>
-        </p:txBody>
-      </p:sp>
-      <p:sp>
-        <p:nvSpPr>
-          <p:cNvPr id="9" name="TextBox 8"/>
-          <p:cNvSpPr txBox="1"/>
-          <p:nvPr/>
-        </p:nvSpPr>
-        <p:spPr>
-          <a:xfrm>
-            <a:off x="777240" y="4608576"/>
-            <a:ext cx="457200" cy="365760"/>
+              <a:rPr sz="1600" b="1" i="0">
+                <a:solidFill>
+                  <a:srgbClr val="141B2D"/>
+                </a:solidFill>
+                <a:latin typeface="Segoe UI"/>
+              </a:rPr>
+              <a:t>Visibilidade</a:t>
+            </a:r>
+          </a:p>
+        </p:txBody>
+      </p:sp>
+      <p:sp>
+        <p:nvSpPr>
+          <p:cNvPr id="12" name="TextBox 11"/>
+          <p:cNvSpPr txBox="1"/>
+          <p:nvPr/>
+        </p:nvSpPr>
+        <p:spPr>
+          <a:xfrm>
+            <a:off x="4636922" y="3200400"/>
+            <a:ext cx="2917850" cy="1828800"/>
+          </a:xfrm>
+          <a:prstGeom prst="rect">
+            <a:avLst/>
+          </a:prstGeom>
+          <a:noFill/>
+        </p:spPr>
+        <p:txBody>
+          <a:bodyPr wrap="square" anchor="t" lIns="0" rIns="0" tIns="0" bIns="0">
+            <a:spAutoFit/>
+          </a:bodyPr>
+          <a:lstStyle/>
+          <a:p>
+            <a:pPr algn="l">
+              <a:lnSpc>
+                <a:spcPct val="125000"/>
+              </a:lnSpc>
+            </a:pPr>
+            <a:r>
+              <a:rPr sz="1200" b="0" i="0">
+                <a:solidFill>
+                  <a:srgbClr val="5A6270"/>
+                </a:solidFill>
+                <a:latin typeface="Segoe UI"/>
+              </a:rPr>
+              <a:t>Métricas de negócio.</a:t>
+            </a:r>
+          </a:p>
+          <a:p>
+            <a:pPr algn="l">
+              <a:lnSpc>
+                <a:spcPct val="125000"/>
+              </a:lnSpc>
+            </a:pPr>
+            <a:r>
+              <a:rPr sz="1200" b="0" i="0">
+                <a:solidFill>
+                  <a:srgbClr val="5A6270"/>
+                </a:solidFill>
+                <a:latin typeface="Segoe UI"/>
+              </a:rPr>
+              <a:t/>
+            </a:r>
+          </a:p>
+          <a:p>
+            <a:pPr algn="l">
+              <a:lnSpc>
+                <a:spcPct val="125000"/>
+              </a:lnSpc>
+            </a:pPr>
+            <a:r>
+              <a:rPr sz="1200" b="0" i="0">
+                <a:solidFill>
+                  <a:srgbClr val="5A6270"/>
+                </a:solidFill>
+                <a:latin typeface="Segoe UI"/>
+              </a:rPr>
+              <a:t>Logs estruturados correlacionados aos traces.</a:t>
+            </a:r>
+          </a:p>
+          <a:p>
+            <a:pPr algn="l">
+              <a:lnSpc>
+                <a:spcPct val="125000"/>
+              </a:lnSpc>
+            </a:pPr>
+            <a:r>
+              <a:rPr sz="1200" b="0" i="0">
+                <a:solidFill>
+                  <a:srgbClr val="5A6270"/>
+                </a:solidFill>
+                <a:latin typeface="Segoe UI"/>
+              </a:rPr>
+              <a:t/>
+            </a:r>
+          </a:p>
+          <a:p>
+            <a:pPr algn="l">
+              <a:lnSpc>
+                <a:spcPct val="125000"/>
+              </a:lnSpc>
+            </a:pPr>
+            <a:r>
+              <a:rPr sz="1200" b="0" i="0">
+                <a:solidFill>
+                  <a:srgbClr val="5A6270"/>
+                </a:solidFill>
+                <a:latin typeface="Segoe UI"/>
+              </a:rPr>
+              <a:t>Alertas associados a runbooks.</a:t>
+            </a:r>
+          </a:p>
+        </p:txBody>
+      </p:sp>
+      <p:sp>
+        <p:nvSpPr>
+          <p:cNvPr id="13" name="Rectangle 12"/>
+          <p:cNvSpPr/>
+          <p:nvPr/>
+        </p:nvSpPr>
+        <p:spPr>
+          <a:xfrm>
+            <a:off x="8039404" y="1965960"/>
+            <a:ext cx="3375050" cy="3291840"/>
+          </a:xfrm>
+          <a:prstGeom prst="rect">
+            <a:avLst/>
+          </a:prstGeom>
+          <a:solidFill>
+            <a:srgbClr val="E9EDF2"/>
+          </a:solidFill>
+          <a:ln>
+            <a:noFill/>
+          </a:ln>
+          <a:effectLst/>
+        </p:spPr>
+        <p:style>
+          <a:lnRef idx="1">
+            <a:schemeClr val="accent1"/>
+          </a:lnRef>
+          <a:fillRef idx="3">
+            <a:schemeClr val="accent1"/>
+          </a:fillRef>
+          <a:effectRef idx="2">
+            <a:schemeClr val="accent1"/>
+          </a:effectRef>
+          <a:fontRef idx="minor">
+            <a:schemeClr val="lt1"/>
+          </a:fontRef>
+        </p:style>
+        <p:txBody>
+          <a:bodyPr rtlCol="0" anchor="ctr"/>
+          <a:lstStyle/>
+          <a:p>
+            <a:pPr algn="ctr"/>
+          </a:p>
+        </p:txBody>
+      </p:sp>
+      <p:sp>
+        <p:nvSpPr>
+          <p:cNvPr id="14" name="TextBox 13"/>
+          <p:cNvSpPr txBox="1"/>
+          <p:nvPr/>
+        </p:nvSpPr>
+        <p:spPr>
+          <a:xfrm>
+            <a:off x="8268004" y="2185416"/>
+            <a:ext cx="2917850" cy="274320"/>
           </a:xfrm>
           <a:prstGeom prst="rect">
             <a:avLst/>
@@ -5201,27 +5507,27 @@
               </a:lnSpc>
             </a:pPr>
             <a:r>
-              <a:rPr sz="2000" b="1" i="0">
-                <a:solidFill>
-                  <a:srgbClr val="6F9DD9"/>
-                </a:solidFill>
-                <a:latin typeface="Segoe UI"/>
-              </a:rPr>
-              <a:t>3</a:t>
-            </a:r>
-          </a:p>
-        </p:txBody>
-      </p:sp>
-      <p:sp>
-        <p:nvSpPr>
-          <p:cNvPr id="10" name="TextBox 9"/>
-          <p:cNvSpPr txBox="1"/>
-          <p:nvPr/>
-        </p:nvSpPr>
-        <p:spPr>
-          <a:xfrm>
-            <a:off x="1417320" y="4645152"/>
-            <a:ext cx="9814255" cy="365760"/>
+              <a:rPr sz="1000" b="1" i="0">
+                <a:solidFill>
+                  <a:srgbClr val="2B5C9B"/>
+                </a:solidFill>
+                <a:latin typeface="Segoe UI"/>
+              </a:rPr>
+              <a:t>ENTREGUE</a:t>
+            </a:r>
+          </a:p>
+        </p:txBody>
+      </p:sp>
+      <p:sp>
+        <p:nvSpPr>
+          <p:cNvPr id="15" name="TextBox 14"/>
+          <p:cNvSpPr txBox="1"/>
+          <p:nvPr/>
+        </p:nvSpPr>
+        <p:spPr>
+          <a:xfrm>
+            <a:off x="8268004" y="2532888"/>
+            <a:ext cx="2917850" cy="548640"/>
           </a:xfrm>
           <a:prstGeom prst="rect">
             <a:avLst/>
@@ -5240,27 +5546,98 @@
               </a:lnSpc>
             </a:pPr>
             <a:r>
-              <a:rPr sz="1500" b="0" i="0">
-                <a:solidFill>
-                  <a:srgbClr val="FAFAF7"/>
-                </a:solidFill>
-                <a:latin typeface="Segoe UI"/>
-              </a:rPr>
-              <a:t>CPF inválido → 400. CPF sem cadastro e cliente bloqueado → 401 idêntico.</a:t>
-            </a:r>
-          </a:p>
-        </p:txBody>
-      </p:sp>
-      <p:sp>
-        <p:nvSpPr>
-          <p:cNvPr id="11" name="TextBox 10"/>
-          <p:cNvSpPr txBox="1"/>
-          <p:nvPr/>
-        </p:nvSpPr>
-        <p:spPr>
-          <a:xfrm>
-            <a:off x="777240" y="5266944"/>
-            <a:ext cx="457200" cy="365760"/>
+              <a:rPr sz="1600" b="1" i="0">
+                <a:solidFill>
+                  <a:srgbClr val="141B2D"/>
+                </a:solidFill>
+                <a:latin typeface="Segoe UI"/>
+              </a:rPr>
+              <a:t>Qualidade</a:t>
+            </a:r>
+          </a:p>
+        </p:txBody>
+      </p:sp>
+      <p:sp>
+        <p:nvSpPr>
+          <p:cNvPr id="16" name="TextBox 15"/>
+          <p:cNvSpPr txBox="1"/>
+          <p:nvPr/>
+        </p:nvSpPr>
+        <p:spPr>
+          <a:xfrm>
+            <a:off x="8268004" y="3200400"/>
+            <a:ext cx="2917850" cy="1828800"/>
+          </a:xfrm>
+          <a:prstGeom prst="rect">
+            <a:avLst/>
+          </a:prstGeom>
+          <a:noFill/>
+        </p:spPr>
+        <p:txBody>
+          <a:bodyPr wrap="square" anchor="t" lIns="0" rIns="0" tIns="0" bIns="0">
+            <a:spAutoFit/>
+          </a:bodyPr>
+          <a:lstStyle/>
+          <a:p>
+            <a:pPr algn="l">
+              <a:lnSpc>
+                <a:spcPct val="125000"/>
+              </a:lnSpc>
+            </a:pPr>
+            <a:r>
+              <a:rPr sz="1200" b="0" i="0">
+                <a:solidFill>
+                  <a:srgbClr val="5A6270"/>
+                </a:solidFill>
+                <a:latin typeface="Segoe UI"/>
+              </a:rPr>
+              <a:t>144 casos de teste na aplicação e 44 na Lambda, com limite mínimo de cobertura.</a:t>
+            </a:r>
+          </a:p>
+          <a:p>
+            <a:pPr algn="l">
+              <a:lnSpc>
+                <a:spcPct val="125000"/>
+              </a:lnSpc>
+            </a:pPr>
+            <a:r>
+              <a:rPr sz="1200" b="0" i="0">
+                <a:solidFill>
+                  <a:srgbClr val="5A6270"/>
+                </a:solidFill>
+                <a:latin typeface="Segoe UI"/>
+              </a:rPr>
+              <a:t/>
+            </a:r>
+          </a:p>
+          <a:p>
+            <a:pPr algn="l">
+              <a:lnSpc>
+                <a:spcPct val="125000"/>
+              </a:lnSpc>
+            </a:pPr>
+            <a:r>
+              <a:rPr sz="1200" b="0" i="0">
+                <a:solidFill>
+                  <a:srgbClr val="5A6270"/>
+                </a:solidFill>
+                <a:latin typeface="Segoe UI"/>
+              </a:rPr>
+              <a:t>Contrato OpenAPI verificado, tflint e checkov na infraestrutura.</a:t>
+            </a:r>
+          </a:p>
+        </p:txBody>
+      </p:sp>
+      <p:sp>
+        <p:nvSpPr>
+          <p:cNvPr id="17" name="TextBox 16"/>
+          <p:cNvSpPr txBox="1"/>
+          <p:nvPr/>
+        </p:nvSpPr>
+        <p:spPr>
+          <a:xfrm>
+            <a:off x="777240" y="6199632"/>
+            <a:ext cx="10637215" cy="320040"/>
           </a:xfrm>
           <a:prstGeom prst="rect">
             <a:avLst/>
@@ -5279,52 +5656,13 @@
               </a:lnSpc>
             </a:pPr>
             <a:r>
-              <a:rPr sz="2000" b="1" i="0">
-                <a:solidFill>
-                  <a:srgbClr val="6F9DD9"/>
-                </a:solidFill>
-                <a:latin typeface="Segoe UI"/>
-              </a:rPr>
-              <a:t>4</a:t>
-            </a:r>
-          </a:p>
-        </p:txBody>
-      </p:sp>
-      <p:sp>
-        <p:nvSpPr>
-          <p:cNvPr id="12" name="TextBox 11"/>
-          <p:cNvSpPr txBox="1"/>
-          <p:nvPr/>
-        </p:nvSpPr>
-        <p:spPr>
-          <a:xfrm>
-            <a:off x="1417320" y="5303520"/>
-            <a:ext cx="9814255" cy="365760"/>
-          </a:xfrm>
-          <a:prstGeom prst="rect">
-            <a:avLst/>
-          </a:prstGeom>
-          <a:noFill/>
-        </p:spPr>
-        <p:txBody>
-          <a:bodyPr wrap="square" anchor="t" lIns="0" rIns="0" tIns="0" bIns="0">
-            <a:spAutoFit/>
-          </a:bodyPr>
-          <a:lstStyle/>
-          <a:p>
-            <a:pPr algn="l">
-              <a:lnSpc>
-                <a:spcPct val="115000"/>
-              </a:lnSpc>
-            </a:pPr>
-            <a:r>
-              <a:rPr sz="1500" b="0" i="0">
-                <a:solidFill>
-                  <a:srgbClr val="FAFAF7"/>
-                </a:solidFill>
-                <a:latin typeface="Segoe UI"/>
-              </a:rPr>
-              <a:t>Com o token: listar OS, abrir uma nova, consultar status.</a:t>
+              <a:rPr sz="1100" b="0" i="1">
+                <a:solidFill>
+                  <a:srgbClr val="5A6270"/>
+                </a:solidFill>
+                <a:latin typeface="Segoe UI"/>
+              </a:rPr>
+              <a:t>Débitos técnicos registrados em docs/tech-challenge-3/debitos-tecnicos.md.</a:t>
             </a:r>
           </a:p>
         </p:txBody>
@@ -5399,7 +5737,7 @@
         </p:nvSpPr>
         <p:spPr>
           <a:xfrm>
-            <a:off x="777240" y="1371600"/>
+            <a:off x="777240" y="822960"/>
             <a:ext cx="10637215" cy="822960"/>
           </a:xfrm>
           <a:prstGeom prst="rect">
@@ -5419,13 +5757,13 @@
               </a:lnSpc>
             </a:pPr>
             <a:r>
-              <a:rPr sz="5400" b="1" i="0">
+              <a:rPr sz="4800" b="1" i="0">
                 <a:solidFill>
                   <a:srgbClr val="FAFAF7"/>
                 </a:solidFill>
                 <a:latin typeface="Segoe UI"/>
               </a:rPr>
-              <a:t>DEMO 2</a:t>
+              <a:t>DEMONSTRAÇÃO</a:t>
             </a:r>
           </a:p>
         </p:txBody>
@@ -5438,7 +5776,7 @@
         </p:nvSpPr>
         <p:spPr>
           <a:xfrm>
-            <a:off x="777240" y="2331720"/>
+            <a:off x="777240" y="1691640"/>
             <a:ext cx="10637215" cy="457200"/>
           </a:xfrm>
           <a:prstGeom prst="rect">
@@ -5464,7 +5802,7 @@
                 </a:solidFill>
                 <a:latin typeface="Segoe UI"/>
               </a:rPr>
-              <a:t>Esteira, deploy e observabilidade ao vivo</a:t>
+              <a:t>Fluxo principal em homologação</a:t>
             </a:r>
           </a:p>
         </p:txBody>
@@ -5477,7 +5815,7 @@
         </p:nvSpPr>
         <p:spPr>
           <a:xfrm>
-            <a:off x="777240" y="3291840"/>
+            <a:off x="777240" y="2514600"/>
             <a:ext cx="457200" cy="365760"/>
           </a:xfrm>
           <a:prstGeom prst="rect">
@@ -5497,7 +5835,7 @@
               </a:lnSpc>
             </a:pPr>
             <a:r>
-              <a:rPr sz="2000" b="1" i="0">
+              <a:rPr sz="1800" b="1" i="0">
                 <a:solidFill>
                   <a:srgbClr val="6F9DD9"/>
                 </a:solidFill>
@@ -5516,7 +5854,7 @@
         </p:nvSpPr>
         <p:spPr>
           <a:xfrm>
-            <a:off x="1417320" y="3328416"/>
+            <a:off x="1417320" y="2542032"/>
             <a:ext cx="9814255" cy="365760"/>
           </a:xfrm>
           <a:prstGeom prst="rect">
@@ -5542,7 +5880,7 @@
                 </a:solidFill>
                 <a:latin typeface="Segoe UI"/>
               </a:rPr>
-              <a:t>Merge do PR na develop → pipeline: testes e imagem no ECR de homologação.</a:t>
+              <a:t>Merge de um PR na develop: a esteira começa a rodar.</a:t>
             </a:r>
           </a:p>
         </p:txBody>
@@ -5555,7 +5893,7 @@
         </p:nvSpPr>
         <p:spPr>
           <a:xfrm>
-            <a:off x="777240" y="3950208"/>
+            <a:off x="777240" y="3044952"/>
             <a:ext cx="457200" cy="365760"/>
           </a:xfrm>
           <a:prstGeom prst="rect">
@@ -5575,7 +5913,7 @@
               </a:lnSpc>
             </a:pPr>
             <a:r>
-              <a:rPr sz="2000" b="1" i="0">
+              <a:rPr sz="1800" b="1" i="0">
                 <a:solidFill>
                   <a:srgbClr val="6F9DD9"/>
                 </a:solidFill>
@@ -5594,7 +5932,7 @@
         </p:nvSpPr>
         <p:spPr>
           <a:xfrm>
-            <a:off x="1417320" y="3986784"/>
+            <a:off x="1417320" y="3072384"/>
             <a:ext cx="9814255" cy="365760"/>
           </a:xfrm>
           <a:prstGeom prst="rect">
@@ -5620,7 +5958,7 @@
                 </a:solidFill>
                 <a:latin typeface="Segoe UI"/>
               </a:rPr>
-              <a:t>Deploy automático no EKS de homologação, até a conclusão do rollout.</a:t>
+              <a:t>Funcionário autentica por CPF e abre uma ordem de serviço.</a:t>
             </a:r>
           </a:p>
         </p:txBody>
@@ -5633,7 +5971,7 @@
         </p:nvSpPr>
         <p:spPr>
           <a:xfrm>
-            <a:off x="777240" y="4608576"/>
+            <a:off x="777240" y="3575304"/>
             <a:ext cx="457200" cy="365760"/>
           </a:xfrm>
           <a:prstGeom prst="rect">
@@ -5653,7 +5991,7 @@
               </a:lnSpc>
             </a:pPr>
             <a:r>
-              <a:rPr sz="2000" b="1" i="0">
+              <a:rPr sz="1800" b="1" i="0">
                 <a:solidFill>
                   <a:srgbClr val="6F9DD9"/>
                 </a:solidFill>
@@ -5672,7 +6010,7 @@
         </p:nvSpPr>
         <p:spPr>
           <a:xfrm>
-            <a:off x="1417320" y="4645152"/>
+            <a:off x="1417320" y="3602736"/>
             <a:ext cx="9814255" cy="365760"/>
           </a:xfrm>
           <a:prstGeom prst="rect">
@@ -5698,7 +6036,7 @@
                 </a:solidFill>
                 <a:latin typeface="Segoe UI"/>
               </a:rPr>
-              <a:t>Carga com k6 → dashboard de negócio e criação de réplica pelo HPA.</a:t>
+              <a:t>Cliente autentica por CPF e recebe o JWT.</a:t>
             </a:r>
           </a:p>
         </p:txBody>
@@ -5711,7 +6049,7 @@
         </p:nvSpPr>
         <p:spPr>
           <a:xfrm>
-            <a:off x="777240" y="5266944"/>
+            <a:off x="777240" y="4105656"/>
             <a:ext cx="457200" cy="365760"/>
           </a:xfrm>
           <a:prstGeom prst="rect">
@@ -5731,7 +6069,7 @@
               </a:lnSpc>
             </a:pPr>
             <a:r>
-              <a:rPr sz="2000" b="1" i="0">
+              <a:rPr sz="1800" b="1" i="0">
                 <a:solidFill>
                   <a:srgbClr val="6F9DD9"/>
                 </a:solidFill>
@@ -5750,7 +6088,7 @@
         </p:nvSpPr>
         <p:spPr>
           <a:xfrm>
-            <a:off x="1417320" y="5303520"/>
+            <a:off x="1417320" y="4133088"/>
             <a:ext cx="9814255" cy="365760"/>
           </a:xfrm>
           <a:prstGeom prst="rect">
@@ -5776,7 +6114,241 @@
                 </a:solidFill>
                 <a:latin typeface="Segoe UI"/>
               </a:rPr>
-              <a:t>Busca pelo ID da OS do DEMO 1: log estruturado → trace distribuído.</a:t>
+              <a:t>Cliente consulta as próprias ordens com o token.</a:t>
+            </a:r>
+          </a:p>
+        </p:txBody>
+      </p:sp>
+      <p:sp>
+        <p:nvSpPr>
+          <p:cNvPr id="13" name="TextBox 12"/>
+          <p:cNvSpPr txBox="1"/>
+          <p:nvPr/>
+        </p:nvSpPr>
+        <p:spPr>
+          <a:xfrm>
+            <a:off x="777240" y="4636008"/>
+            <a:ext cx="457200" cy="365760"/>
+          </a:xfrm>
+          <a:prstGeom prst="rect">
+            <a:avLst/>
+          </a:prstGeom>
+          <a:noFill/>
+        </p:spPr>
+        <p:txBody>
+          <a:bodyPr wrap="square" anchor="t" lIns="0" rIns="0" tIns="0" bIns="0">
+            <a:spAutoFit/>
+          </a:bodyPr>
+          <a:lstStyle/>
+          <a:p>
+            <a:pPr algn="l">
+              <a:lnSpc>
+                <a:spcPct val="115000"/>
+              </a:lnSpc>
+            </a:pPr>
+            <a:r>
+              <a:rPr sz="1800" b="1" i="0">
+                <a:solidFill>
+                  <a:srgbClr val="6F9DD9"/>
+                </a:solidFill>
+                <a:latin typeface="Segoe UI"/>
+              </a:rPr>
+              <a:t>5</a:t>
+            </a:r>
+          </a:p>
+        </p:txBody>
+      </p:sp>
+      <p:sp>
+        <p:nvSpPr>
+          <p:cNvPr id="14" name="TextBox 13"/>
+          <p:cNvSpPr txBox="1"/>
+          <p:nvPr/>
+        </p:nvSpPr>
+        <p:spPr>
+          <a:xfrm>
+            <a:off x="1417320" y="4663440"/>
+            <a:ext cx="9814255" cy="365760"/>
+          </a:xfrm>
+          <a:prstGeom prst="rect">
+            <a:avLst/>
+          </a:prstGeom>
+          <a:noFill/>
+        </p:spPr>
+        <p:txBody>
+          <a:bodyPr wrap="square" anchor="t" lIns="0" rIns="0" tIns="0" bIns="0">
+            <a:spAutoFit/>
+          </a:bodyPr>
+          <a:lstStyle/>
+          <a:p>
+            <a:pPr algn="l">
+              <a:lnSpc>
+                <a:spcPct val="115000"/>
+              </a:lnSpc>
+            </a:pPr>
+            <a:r>
+              <a:rPr sz="1500" b="0" i="0">
+                <a:solidFill>
+                  <a:srgbClr val="FAFAF7"/>
+                </a:solidFill>
+                <a:latin typeface="Segoe UI"/>
+              </a:rPr>
+              <a:t>Esteira: testes, imagem no ECR e deploy automático no EKS.</a:t>
+            </a:r>
+          </a:p>
+        </p:txBody>
+      </p:sp>
+      <p:sp>
+        <p:nvSpPr>
+          <p:cNvPr id="15" name="TextBox 14"/>
+          <p:cNvSpPr txBox="1"/>
+          <p:nvPr/>
+        </p:nvSpPr>
+        <p:spPr>
+          <a:xfrm>
+            <a:off x="777240" y="5166360"/>
+            <a:ext cx="457200" cy="365760"/>
+          </a:xfrm>
+          <a:prstGeom prst="rect">
+            <a:avLst/>
+          </a:prstGeom>
+          <a:noFill/>
+        </p:spPr>
+        <p:txBody>
+          <a:bodyPr wrap="square" anchor="t" lIns="0" rIns="0" tIns="0" bIns="0">
+            <a:spAutoFit/>
+          </a:bodyPr>
+          <a:lstStyle/>
+          <a:p>
+            <a:pPr algn="l">
+              <a:lnSpc>
+                <a:spcPct val="115000"/>
+              </a:lnSpc>
+            </a:pPr>
+            <a:r>
+              <a:rPr sz="1800" b="1" i="0">
+                <a:solidFill>
+                  <a:srgbClr val="6F9DD9"/>
+                </a:solidFill>
+                <a:latin typeface="Segoe UI"/>
+              </a:rPr>
+              <a:t>6</a:t>
+            </a:r>
+          </a:p>
+        </p:txBody>
+      </p:sp>
+      <p:sp>
+        <p:nvSpPr>
+          <p:cNvPr id="16" name="TextBox 15"/>
+          <p:cNvSpPr txBox="1"/>
+          <p:nvPr/>
+        </p:nvSpPr>
+        <p:spPr>
+          <a:xfrm>
+            <a:off x="1417320" y="5193792"/>
+            <a:ext cx="9814255" cy="365760"/>
+          </a:xfrm>
+          <a:prstGeom prst="rect">
+            <a:avLst/>
+          </a:prstGeom>
+          <a:noFill/>
+        </p:spPr>
+        <p:txBody>
+          <a:bodyPr wrap="square" anchor="t" lIns="0" rIns="0" tIns="0" bIns="0">
+            <a:spAutoFit/>
+          </a:bodyPr>
+          <a:lstStyle/>
+          <a:p>
+            <a:pPr algn="l">
+              <a:lnSpc>
+                <a:spcPct val="115000"/>
+              </a:lnSpc>
+            </a:pPr>
+            <a:r>
+              <a:rPr sz="1500" b="0" i="0">
+                <a:solidFill>
+                  <a:srgbClr val="FAFAF7"/>
+                </a:solidFill>
+                <a:latin typeface="Segoe UI"/>
+              </a:rPr>
+              <a:t>Carga com k6: dashboard de negócio e HPA criando réplicas.</a:t>
+            </a:r>
+          </a:p>
+        </p:txBody>
+      </p:sp>
+      <p:sp>
+        <p:nvSpPr>
+          <p:cNvPr id="17" name="TextBox 16"/>
+          <p:cNvSpPr txBox="1"/>
+          <p:nvPr/>
+        </p:nvSpPr>
+        <p:spPr>
+          <a:xfrm>
+            <a:off x="777240" y="5696712"/>
+            <a:ext cx="457200" cy="365760"/>
+          </a:xfrm>
+          <a:prstGeom prst="rect">
+            <a:avLst/>
+          </a:prstGeom>
+          <a:noFill/>
+        </p:spPr>
+        <p:txBody>
+          <a:bodyPr wrap="square" anchor="t" lIns="0" rIns="0" tIns="0" bIns="0">
+            <a:spAutoFit/>
+          </a:bodyPr>
+          <a:lstStyle/>
+          <a:p>
+            <a:pPr algn="l">
+              <a:lnSpc>
+                <a:spcPct val="115000"/>
+              </a:lnSpc>
+            </a:pPr>
+            <a:r>
+              <a:rPr sz="1800" b="1" i="0">
+                <a:solidFill>
+                  <a:srgbClr val="6F9DD9"/>
+                </a:solidFill>
+                <a:latin typeface="Segoe UI"/>
+              </a:rPr>
+              <a:t>7</a:t>
+            </a:r>
+          </a:p>
+        </p:txBody>
+      </p:sp>
+      <p:sp>
+        <p:nvSpPr>
+          <p:cNvPr id="18" name="TextBox 17"/>
+          <p:cNvSpPr txBox="1"/>
+          <p:nvPr/>
+        </p:nvSpPr>
+        <p:spPr>
+          <a:xfrm>
+            <a:off x="1417320" y="5724144"/>
+            <a:ext cx="9814255" cy="365760"/>
+          </a:xfrm>
+          <a:prstGeom prst="rect">
+            <a:avLst/>
+          </a:prstGeom>
+          <a:noFill/>
+        </p:spPr>
+        <p:txBody>
+          <a:bodyPr wrap="square" anchor="t" lIns="0" rIns="0" tIns="0" bIns="0">
+            <a:spAutoFit/>
+          </a:bodyPr>
+          <a:lstStyle/>
+          <a:p>
+            <a:pPr algn="l">
+              <a:lnSpc>
+                <a:spcPct val="115000"/>
+              </a:lnSpc>
+            </a:pPr>
+            <a:r>
+              <a:rPr sz="1500" b="0" i="0">
+                <a:solidFill>
+                  <a:srgbClr val="FAFAF7"/>
+                </a:solidFill>
+                <a:latin typeface="Segoe UI"/>
+              </a:rPr>
+              <a:t>Busca pela ordem criada: log estruturado e trace distribuído.</a:t>
             </a:r>
           </a:p>
         </p:txBody>
@@ -5814,7 +6386,7 @@
             <a:avLst/>
           </a:prstGeom>
           <a:solidFill>
-            <a:srgbClr val="FAFAF7"/>
+            <a:srgbClr val="141B2D"/>
           </a:solidFill>
           <a:ln>
             <a:noFill/>
@@ -5851,8 +6423,8 @@
         </p:nvSpPr>
         <p:spPr>
           <a:xfrm>
-            <a:off x="777240" y="502920"/>
-            <a:ext cx="10637215" cy="640080"/>
+            <a:off x="777240" y="2011680"/>
+            <a:ext cx="10637215" cy="914400"/>
           </a:xfrm>
           <a:prstGeom prst="rect">
             <a:avLst/>
@@ -5871,13 +6443,13 @@
               </a:lnSpc>
             </a:pPr>
             <a:r>
-              <a:rPr sz="3000" b="1" i="0">
-                <a:solidFill>
-                  <a:srgbClr val="141B2D"/>
-                </a:solidFill>
-                <a:latin typeface="Segoe UI"/>
-              </a:rPr>
-              <a:t>Resultados</a:t>
+              <a:rPr sz="4800" b="1" i="0">
+                <a:solidFill>
+                  <a:srgbClr val="FAFAF7"/>
+                </a:solidFill>
+                <a:latin typeface="Segoe UI"/>
+              </a:rPr>
+              <a:t>Obrigado.</a:t>
             </a:r>
           </a:p>
         </p:txBody>
@@ -5890,8 +6462,95 @@
         </p:nvSpPr>
         <p:spPr>
           <a:xfrm>
-            <a:off x="777240" y="1170432"/>
-            <a:ext cx="10637215" cy="457200"/>
+            <a:off x="777240" y="3200400"/>
+            <a:ext cx="10637215" cy="1463040"/>
+          </a:xfrm>
+          <a:prstGeom prst="rect">
+            <a:avLst/>
+          </a:prstGeom>
+          <a:noFill/>
+        </p:spPr>
+        <p:txBody>
+          <a:bodyPr wrap="square" anchor="t" lIns="0" rIns="0" tIns="0" bIns="0">
+            <a:spAutoFit/>
+          </a:bodyPr>
+          <a:lstStyle/>
+          <a:p>
+            <a:pPr algn="l">
+              <a:lnSpc>
+                <a:spcPct val="150000"/>
+              </a:lnSpc>
+            </a:pPr>
+            <a:r>
+              <a:rPr sz="1600" b="0" i="0">
+                <a:solidFill>
+                  <a:srgbClr val="B9C4D4"/>
+                </a:solidFill>
+                <a:latin typeface="Segoe UI"/>
+              </a:rPr>
+              <a:t>github.com/Guilherme-Fumagali/tech-challenge-1</a:t>
+            </a:r>
+          </a:p>
+          <a:p>
+            <a:pPr algn="l">
+              <a:lnSpc>
+                <a:spcPct val="150000"/>
+              </a:lnSpc>
+            </a:pPr>
+            <a:r>
+              <a:rPr sz="1600" b="0" i="0">
+                <a:solidFill>
+                  <a:srgbClr val="B9C4D4"/>
+                </a:solidFill>
+                <a:latin typeface="Segoe UI"/>
+              </a:rPr>
+              <a:t>github.com/Guilherme-Fumagali/oficina-auth-lambda</a:t>
+            </a:r>
+          </a:p>
+          <a:p>
+            <a:pPr algn="l">
+              <a:lnSpc>
+                <a:spcPct val="150000"/>
+              </a:lnSpc>
+            </a:pPr>
+            <a:r>
+              <a:rPr sz="1600" b="0" i="0">
+                <a:solidFill>
+                  <a:srgbClr val="B9C4D4"/>
+                </a:solidFill>
+                <a:latin typeface="Segoe UI"/>
+              </a:rPr>
+              <a:t>github.com/Guilherme-Fumagali/oficina-infra-k8s</a:t>
+            </a:r>
+          </a:p>
+          <a:p>
+            <a:pPr algn="l">
+              <a:lnSpc>
+                <a:spcPct val="150000"/>
+              </a:lnSpc>
+            </a:pPr>
+            <a:r>
+              <a:rPr sz="1600" b="0" i="0">
+                <a:solidFill>
+                  <a:srgbClr val="B9C4D4"/>
+                </a:solidFill>
+                <a:latin typeface="Segoe UI"/>
+              </a:rPr>
+              <a:t>github.com/Guilherme-Fumagali/oficina-infra-db</a:t>
+            </a:r>
+          </a:p>
+        </p:txBody>
+      </p:sp>
+      <p:sp>
+        <p:nvSpPr>
+          <p:cNvPr id="5" name="TextBox 4"/>
+          <p:cNvSpPr txBox="1"/>
+          <p:nvPr/>
+        </p:nvSpPr>
+        <p:spPr>
+          <a:xfrm>
+            <a:off x="777240" y="5989320"/>
+            <a:ext cx="10637215" cy="365760"/>
           </a:xfrm>
           <a:prstGeom prst="rect">
             <a:avLst/>
@@ -5910,663 +6569,13 @@
               </a:lnSpc>
             </a:pPr>
             <a:r>
-              <a:rPr sz="1400" b="0" i="0">
-                <a:solidFill>
-                  <a:srgbClr val="5A6270"/>
-                </a:solidFill>
-                <a:latin typeface="Segoe UI"/>
-              </a:rPr>
-              <a:t>Entregas da fase e débitos técnicos registrados.</a:t>
-            </a:r>
-          </a:p>
-        </p:txBody>
-      </p:sp>
-      <p:sp>
-        <p:nvSpPr>
-          <p:cNvPr id="5" name="Rectangle 4"/>
-          <p:cNvSpPr/>
-          <p:nvPr/>
-        </p:nvSpPr>
-        <p:spPr>
-          <a:xfrm>
-            <a:off x="777240" y="1965960"/>
-            <a:ext cx="3375050" cy="3108960"/>
-          </a:xfrm>
-          <a:prstGeom prst="rect">
-            <a:avLst/>
-          </a:prstGeom>
-          <a:solidFill>
-            <a:srgbClr val="E9EDF2"/>
-          </a:solidFill>
-          <a:ln>
-            <a:noFill/>
-          </a:ln>
-          <a:effectLst/>
-        </p:spPr>
-        <p:style>
-          <a:lnRef idx="1">
-            <a:schemeClr val="accent1"/>
-          </a:lnRef>
-          <a:fillRef idx="3">
-            <a:schemeClr val="accent1"/>
-          </a:fillRef>
-          <a:effectRef idx="2">
-            <a:schemeClr val="accent1"/>
-          </a:effectRef>
-          <a:fontRef idx="minor">
-            <a:schemeClr val="lt1"/>
-          </a:fontRef>
-        </p:style>
-        <p:txBody>
-          <a:bodyPr rtlCol="0" anchor="ctr"/>
-          <a:lstStyle/>
-          <a:p>
-            <a:pPr algn="ctr"/>
-          </a:p>
-        </p:txBody>
-      </p:sp>
-      <p:sp>
-        <p:nvSpPr>
-          <p:cNvPr id="6" name="TextBox 5"/>
-          <p:cNvSpPr txBox="1"/>
-          <p:nvPr/>
-        </p:nvSpPr>
-        <p:spPr>
-          <a:xfrm>
-            <a:off x="1005840" y="2185416"/>
-            <a:ext cx="2917850" cy="274320"/>
-          </a:xfrm>
-          <a:prstGeom prst="rect">
-            <a:avLst/>
-          </a:prstGeom>
-          <a:noFill/>
-        </p:spPr>
-        <p:txBody>
-          <a:bodyPr wrap="square" anchor="t" lIns="0" rIns="0" tIns="0" bIns="0">
-            <a:spAutoFit/>
-          </a:bodyPr>
-          <a:lstStyle/>
-          <a:p>
-            <a:pPr algn="l">
-              <a:lnSpc>
-                <a:spcPct val="115000"/>
-              </a:lnSpc>
-            </a:pPr>
-            <a:r>
-              <a:rPr sz="1000" b="1" i="0">
-                <a:solidFill>
-                  <a:srgbClr val="2B5C9B"/>
-                </a:solidFill>
-                <a:latin typeface="Segoe UI"/>
-              </a:rPr>
-              <a:t>ENTREGUE</a:t>
-            </a:r>
-          </a:p>
-        </p:txBody>
-      </p:sp>
-      <p:sp>
-        <p:nvSpPr>
-          <p:cNvPr id="7" name="TextBox 6"/>
-          <p:cNvSpPr txBox="1"/>
-          <p:nvPr/>
-        </p:nvSpPr>
-        <p:spPr>
-          <a:xfrm>
-            <a:off x="1005840" y="2532888"/>
-            <a:ext cx="2917850" cy="548640"/>
-          </a:xfrm>
-          <a:prstGeom prst="rect">
-            <a:avLst/>
-          </a:prstGeom>
-          <a:noFill/>
-        </p:spPr>
-        <p:txBody>
-          <a:bodyPr wrap="square" anchor="t" lIns="0" rIns="0" tIns="0" bIns="0">
-            <a:spAutoFit/>
-          </a:bodyPr>
-          <a:lstStyle/>
-          <a:p>
-            <a:pPr algn="l">
-              <a:lnSpc>
-                <a:spcPct val="115000"/>
-              </a:lnSpc>
-            </a:pPr>
-            <a:r>
-              <a:rPr sz="1600" b="1" i="0">
-                <a:solidFill>
-                  <a:srgbClr val="141B2D"/>
-                </a:solidFill>
-                <a:latin typeface="Segoe UI"/>
-              </a:rPr>
-              <a:t>Operação</a:t>
-            </a:r>
-          </a:p>
-        </p:txBody>
-      </p:sp>
-      <p:sp>
-        <p:nvSpPr>
-          <p:cNvPr id="8" name="TextBox 7"/>
-          <p:cNvSpPr txBox="1"/>
-          <p:nvPr/>
-        </p:nvSpPr>
-        <p:spPr>
-          <a:xfrm>
-            <a:off x="1005840" y="3200400"/>
-            <a:ext cx="2917850" cy="1645920"/>
-          </a:xfrm>
-          <a:prstGeom prst="rect">
-            <a:avLst/>
-          </a:prstGeom>
-          <a:noFill/>
-        </p:spPr>
-        <p:txBody>
-          <a:bodyPr wrap="square" anchor="t" lIns="0" rIns="0" tIns="0" bIns="0">
-            <a:spAutoFit/>
-          </a:bodyPr>
-          <a:lstStyle/>
-          <a:p>
-            <a:pPr algn="l">
-              <a:lnSpc>
-                <a:spcPct val="125000"/>
-              </a:lnSpc>
-            </a:pPr>
-            <a:r>
               <a:rPr sz="1200" b="0" i="0">
                 <a:solidFill>
-                  <a:srgbClr val="5A6270"/>
-                </a:solidFill>
-                <a:latin typeface="Segoe UI"/>
-              </a:rPr>
-              <a:t>Autenticação fora da aplicação, borda protegida por gateway e rede privada.</a:t>
-            </a:r>
-          </a:p>
-          <a:p>
-            <a:pPr algn="l">
-              <a:lnSpc>
-                <a:spcPct val="125000"/>
-              </a:lnSpc>
-            </a:pPr>
-            <a:r>
-              <a:rPr sz="1200" b="0" i="0">
-                <a:solidFill>
-                  <a:srgbClr val="5A6270"/>
-                </a:solidFill>
-                <a:latin typeface="Segoe UI"/>
-              </a:rPr>
-              <a:t/>
-            </a:r>
-          </a:p>
-          <a:p>
-            <a:pPr algn="l">
-              <a:lnSpc>
-                <a:spcPct val="125000"/>
-              </a:lnSpc>
-            </a:pPr>
-            <a:r>
-              <a:rPr sz="1200" b="0" i="0">
-                <a:solidFill>
-                  <a:srgbClr val="5A6270"/>
-                </a:solidFill>
-                <a:latin typeface="Segoe UI"/>
-              </a:rPr>
-              <a:t>Quatro pipelines com menor privilégio e dois ambientes segregados.</a:t>
-            </a:r>
-          </a:p>
-        </p:txBody>
-      </p:sp>
-      <p:sp>
-        <p:nvSpPr>
-          <p:cNvPr id="9" name="Rectangle 8"/>
-          <p:cNvSpPr/>
-          <p:nvPr/>
-        </p:nvSpPr>
-        <p:spPr>
-          <a:xfrm>
-            <a:off x="4408322" y="1965960"/>
-            <a:ext cx="3375050" cy="3108960"/>
-          </a:xfrm>
-          <a:prstGeom prst="rect">
-            <a:avLst/>
-          </a:prstGeom>
-          <a:solidFill>
-            <a:srgbClr val="E9EDF2"/>
-          </a:solidFill>
-          <a:ln>
-            <a:noFill/>
-          </a:ln>
-          <a:effectLst/>
-        </p:spPr>
-        <p:style>
-          <a:lnRef idx="1">
-            <a:schemeClr val="accent1"/>
-          </a:lnRef>
-          <a:fillRef idx="3">
-            <a:schemeClr val="accent1"/>
-          </a:fillRef>
-          <a:effectRef idx="2">
-            <a:schemeClr val="accent1"/>
-          </a:effectRef>
-          <a:fontRef idx="minor">
-            <a:schemeClr val="lt1"/>
-          </a:fontRef>
-        </p:style>
-        <p:txBody>
-          <a:bodyPr rtlCol="0" anchor="ctr"/>
-          <a:lstStyle/>
-          <a:p>
-            <a:pPr algn="ctr"/>
-          </a:p>
-        </p:txBody>
-      </p:sp>
-      <p:sp>
-        <p:nvSpPr>
-          <p:cNvPr id="10" name="TextBox 9"/>
-          <p:cNvSpPr txBox="1"/>
-          <p:nvPr/>
-        </p:nvSpPr>
-        <p:spPr>
-          <a:xfrm>
-            <a:off x="4636922" y="2185416"/>
-            <a:ext cx="2917850" cy="274320"/>
-          </a:xfrm>
-          <a:prstGeom prst="rect">
-            <a:avLst/>
-          </a:prstGeom>
-          <a:noFill/>
-        </p:spPr>
-        <p:txBody>
-          <a:bodyPr wrap="square" anchor="t" lIns="0" rIns="0" tIns="0" bIns="0">
-            <a:spAutoFit/>
-          </a:bodyPr>
-          <a:lstStyle/>
-          <a:p>
-            <a:pPr algn="l">
-              <a:lnSpc>
-                <a:spcPct val="115000"/>
-              </a:lnSpc>
-            </a:pPr>
-            <a:r>
-              <a:rPr sz="1000" b="1" i="0">
-                <a:solidFill>
-                  <a:srgbClr val="2B5C9B"/>
-                </a:solidFill>
-                <a:latin typeface="Segoe UI"/>
-              </a:rPr>
-              <a:t>ENTREGUE</a:t>
-            </a:r>
-          </a:p>
-        </p:txBody>
-      </p:sp>
-      <p:sp>
-        <p:nvSpPr>
-          <p:cNvPr id="11" name="TextBox 10"/>
-          <p:cNvSpPr txBox="1"/>
-          <p:nvPr/>
-        </p:nvSpPr>
-        <p:spPr>
-          <a:xfrm>
-            <a:off x="4636922" y="2532888"/>
-            <a:ext cx="2917850" cy="548640"/>
-          </a:xfrm>
-          <a:prstGeom prst="rect">
-            <a:avLst/>
-          </a:prstGeom>
-          <a:noFill/>
-        </p:spPr>
-        <p:txBody>
-          <a:bodyPr wrap="square" anchor="t" lIns="0" rIns="0" tIns="0" bIns="0">
-            <a:spAutoFit/>
-          </a:bodyPr>
-          <a:lstStyle/>
-          <a:p>
-            <a:pPr algn="l">
-              <a:lnSpc>
-                <a:spcPct val="115000"/>
-              </a:lnSpc>
-            </a:pPr>
-            <a:r>
-              <a:rPr sz="1600" b="1" i="0">
-                <a:solidFill>
-                  <a:srgbClr val="141B2D"/>
-                </a:solidFill>
-                <a:latin typeface="Segoe UI"/>
-              </a:rPr>
-              <a:t>Visibilidade</a:t>
-            </a:r>
-          </a:p>
-        </p:txBody>
-      </p:sp>
-      <p:sp>
-        <p:nvSpPr>
-          <p:cNvPr id="12" name="TextBox 11"/>
-          <p:cNvSpPr txBox="1"/>
-          <p:nvPr/>
-        </p:nvSpPr>
-        <p:spPr>
-          <a:xfrm>
-            <a:off x="4636922" y="3200400"/>
-            <a:ext cx="2917850" cy="1645920"/>
-          </a:xfrm>
-          <a:prstGeom prst="rect">
-            <a:avLst/>
-          </a:prstGeom>
-          <a:noFill/>
-        </p:spPr>
-        <p:txBody>
-          <a:bodyPr wrap="square" anchor="t" lIns="0" rIns="0" tIns="0" bIns="0">
-            <a:spAutoFit/>
-          </a:bodyPr>
-          <a:lstStyle/>
-          <a:p>
-            <a:pPr algn="l">
-              <a:lnSpc>
-                <a:spcPct val="125000"/>
-              </a:lnSpc>
-            </a:pPr>
-            <a:r>
-              <a:rPr sz="1200" b="0" i="0">
-                <a:solidFill>
-                  <a:srgbClr val="5A6270"/>
-                </a:solidFill>
-                <a:latin typeface="Segoe UI"/>
-              </a:rPr>
-              <a:t>Métricas de negócio.</a:t>
-            </a:r>
-          </a:p>
-          <a:p>
-            <a:pPr algn="l">
-              <a:lnSpc>
-                <a:spcPct val="125000"/>
-              </a:lnSpc>
-            </a:pPr>
-            <a:r>
-              <a:rPr sz="1200" b="0" i="0">
-                <a:solidFill>
-                  <a:srgbClr val="5A6270"/>
-                </a:solidFill>
-                <a:latin typeface="Segoe UI"/>
-              </a:rPr>
-              <a:t/>
-            </a:r>
-          </a:p>
-          <a:p>
-            <a:pPr algn="l">
-              <a:lnSpc>
-                <a:spcPct val="125000"/>
-              </a:lnSpc>
-            </a:pPr>
-            <a:r>
-              <a:rPr sz="1200" b="0" i="0">
-                <a:solidFill>
-                  <a:srgbClr val="5A6270"/>
-                </a:solidFill>
-                <a:latin typeface="Segoe UI"/>
-              </a:rPr>
-              <a:t>Logs estruturados correlacionados aos traces.</a:t>
-            </a:r>
-          </a:p>
-          <a:p>
-            <a:pPr algn="l">
-              <a:lnSpc>
-                <a:spcPct val="125000"/>
-              </a:lnSpc>
-            </a:pPr>
-            <a:r>
-              <a:rPr sz="1200" b="0" i="0">
-                <a:solidFill>
-                  <a:srgbClr val="5A6270"/>
-                </a:solidFill>
-                <a:latin typeface="Segoe UI"/>
-              </a:rPr>
-              <a:t/>
-            </a:r>
-          </a:p>
-          <a:p>
-            <a:pPr algn="l">
-              <a:lnSpc>
-                <a:spcPct val="125000"/>
-              </a:lnSpc>
-            </a:pPr>
-            <a:r>
-              <a:rPr sz="1200" b="0" i="0">
-                <a:solidFill>
-                  <a:srgbClr val="5A6270"/>
-                </a:solidFill>
-                <a:latin typeface="Segoe UI"/>
-              </a:rPr>
-              <a:t>Alertas associados a runbooks.</a:t>
-            </a:r>
-          </a:p>
-        </p:txBody>
-      </p:sp>
-      <p:sp>
-        <p:nvSpPr>
-          <p:cNvPr id="13" name="Rectangle 12"/>
-          <p:cNvSpPr/>
-          <p:nvPr/>
-        </p:nvSpPr>
-        <p:spPr>
-          <a:xfrm>
-            <a:off x="8039404" y="1965960"/>
-            <a:ext cx="3375050" cy="3108960"/>
-          </a:xfrm>
-          <a:prstGeom prst="rect">
-            <a:avLst/>
-          </a:prstGeom>
-          <a:solidFill>
-            <a:srgbClr val="E9EDF2"/>
-          </a:solidFill>
-          <a:ln>
-            <a:noFill/>
-          </a:ln>
-          <a:effectLst/>
-        </p:spPr>
-        <p:style>
-          <a:lnRef idx="1">
-            <a:schemeClr val="accent1"/>
-          </a:lnRef>
-          <a:fillRef idx="3">
-            <a:schemeClr val="accent1"/>
-          </a:fillRef>
-          <a:effectRef idx="2">
-            <a:schemeClr val="accent1"/>
-          </a:effectRef>
-          <a:fontRef idx="minor">
-            <a:schemeClr val="lt1"/>
-          </a:fontRef>
-        </p:style>
-        <p:txBody>
-          <a:bodyPr rtlCol="0" anchor="ctr"/>
-          <a:lstStyle/>
-          <a:p>
-            <a:pPr algn="ctr"/>
-          </a:p>
-        </p:txBody>
-      </p:sp>
-      <p:sp>
-        <p:nvSpPr>
-          <p:cNvPr id="14" name="TextBox 13"/>
-          <p:cNvSpPr txBox="1"/>
-          <p:nvPr/>
-        </p:nvSpPr>
-        <p:spPr>
-          <a:xfrm>
-            <a:off x="8268004" y="2185416"/>
-            <a:ext cx="2917850" cy="274320"/>
-          </a:xfrm>
-          <a:prstGeom prst="rect">
-            <a:avLst/>
-          </a:prstGeom>
-          <a:noFill/>
-        </p:spPr>
-        <p:txBody>
-          <a:bodyPr wrap="square" anchor="t" lIns="0" rIns="0" tIns="0" bIns="0">
-            <a:spAutoFit/>
-          </a:bodyPr>
-          <a:lstStyle/>
-          <a:p>
-            <a:pPr algn="l">
-              <a:lnSpc>
-                <a:spcPct val="115000"/>
-              </a:lnSpc>
-            </a:pPr>
-            <a:r>
-              <a:rPr sz="1000" b="1" i="0">
-                <a:solidFill>
-                  <a:srgbClr val="B36A0B"/>
-                </a:solidFill>
-                <a:latin typeface="Segoe UI"/>
-              </a:rPr>
-              <a:t>REGISTRADO</a:t>
-            </a:r>
-          </a:p>
-        </p:txBody>
-      </p:sp>
-      <p:sp>
-        <p:nvSpPr>
-          <p:cNvPr id="15" name="TextBox 14"/>
-          <p:cNvSpPr txBox="1"/>
-          <p:nvPr/>
-        </p:nvSpPr>
-        <p:spPr>
-          <a:xfrm>
-            <a:off x="8268004" y="2532888"/>
-            <a:ext cx="2917850" cy="548640"/>
-          </a:xfrm>
-          <a:prstGeom prst="rect">
-            <a:avLst/>
-          </a:prstGeom>
-          <a:noFill/>
-        </p:spPr>
-        <p:txBody>
-          <a:bodyPr wrap="square" anchor="t" lIns="0" rIns="0" tIns="0" bIns="0">
-            <a:spAutoFit/>
-          </a:bodyPr>
-          <a:lstStyle/>
-          <a:p>
-            <a:pPr algn="l">
-              <a:lnSpc>
-                <a:spcPct val="115000"/>
-              </a:lnSpc>
-            </a:pPr>
-            <a:r>
-              <a:rPr sz="1600" b="1" i="0">
-                <a:solidFill>
-                  <a:srgbClr val="141B2D"/>
-                </a:solidFill>
-                <a:latin typeface="Segoe UI"/>
-              </a:rPr>
-              <a:t>9 débitos técnicos</a:t>
-            </a:r>
-          </a:p>
-        </p:txBody>
-      </p:sp>
-      <p:sp>
-        <p:nvSpPr>
-          <p:cNvPr id="16" name="TextBox 15"/>
-          <p:cNvSpPr txBox="1"/>
-          <p:nvPr/>
-        </p:nvSpPr>
-        <p:spPr>
-          <a:xfrm>
-            <a:off x="8268004" y="3200400"/>
-            <a:ext cx="2917850" cy="1645920"/>
-          </a:xfrm>
-          <a:prstGeom prst="rect">
-            <a:avLst/>
-          </a:prstGeom>
-          <a:noFill/>
-        </p:spPr>
-        <p:txBody>
-          <a:bodyPr wrap="square" anchor="t" lIns="0" rIns="0" tIns="0" bIns="0">
-            <a:spAutoFit/>
-          </a:bodyPr>
-          <a:lstStyle/>
-          <a:p>
-            <a:pPr algn="l">
-              <a:lnSpc>
-                <a:spcPct val="125000"/>
-              </a:lnSpc>
-            </a:pPr>
-            <a:r>
-              <a:rPr sz="1200" b="0" i="0">
-                <a:solidFill>
-                  <a:srgbClr val="5A6270"/>
-                </a:solidFill>
-                <a:latin typeface="Segoe UI"/>
-              </a:rPr>
-              <a:t>Autenticação só por CPF atende ao enunciado, com mitigações aplicadas.</a:t>
-            </a:r>
-          </a:p>
-          <a:p>
-            <a:pPr algn="l">
-              <a:lnSpc>
-                <a:spcPct val="125000"/>
-              </a:lnSpc>
-            </a:pPr>
-            <a:r>
-              <a:rPr sz="1200" b="0" i="0">
-                <a:solidFill>
-                  <a:srgbClr val="5A6270"/>
-                </a:solidFill>
-                <a:latin typeface="Segoe UI"/>
-              </a:rPr>
-              <a:t/>
-            </a:r>
-          </a:p>
-          <a:p>
-            <a:pPr algn="l">
-              <a:lnSpc>
-                <a:spcPct val="125000"/>
-              </a:lnSpc>
-            </a:pPr>
-            <a:r>
-              <a:rPr sz="1200" b="0" i="0">
-                <a:solidFill>
-                  <a:srgbClr val="5A6270"/>
-                </a:solidFill>
-                <a:latin typeface="Segoe UI"/>
-              </a:rPr>
-              <a:t>O segundo fator fica planejado para uma próxima etapa, fora do escopo desta entrega.</a:t>
-            </a:r>
-          </a:p>
-        </p:txBody>
-      </p:sp>
-      <p:sp>
-        <p:nvSpPr>
-          <p:cNvPr id="17" name="TextBox 16"/>
-          <p:cNvSpPr txBox="1"/>
-          <p:nvPr/>
-        </p:nvSpPr>
-        <p:spPr>
-          <a:xfrm>
-            <a:off x="777240" y="5760720"/>
-            <a:ext cx="10637215" cy="457200"/>
-          </a:xfrm>
-          <a:prstGeom prst="rect">
-            <a:avLst/>
-          </a:prstGeom>
-          <a:noFill/>
-        </p:spPr>
-        <p:txBody>
-          <a:bodyPr wrap="square" anchor="t" lIns="0" rIns="0" tIns="0" bIns="0">
-            <a:spAutoFit/>
-          </a:bodyPr>
-          <a:lstStyle/>
-          <a:p>
-            <a:pPr algn="l">
-              <a:lnSpc>
-                <a:spcPct val="115000"/>
-              </a:lnSpc>
-            </a:pPr>
-            <a:r>
-              <a:rPr sz="2400" b="1" i="0">
-                <a:solidFill>
-                  <a:srgbClr val="141B2D"/>
-                </a:solidFill>
-                <a:latin typeface="Segoe UI"/>
-              </a:rPr>
-              <a:t>Obrigado.</a:t>
+                  <a:srgbClr val="8A97AB"/>
+                </a:solidFill>
+                <a:latin typeface="Segoe UI"/>
+              </a:rPr>
+              <a:t>Danilo Canato — RM 372411 · Guilherme Fumagali Marques — RM 372421</a:t>
             </a:r>
           </a:p>
         </p:txBody>

</xml_diff>

<commit_message>
docs: describe log forwarding through new relic agent
</commit_message>
<xml_diff>
--- a/docs/tech-challenge-3/apresentacao.pptx
+++ b/docs/tech-challenge-3/apresentacao.pptx
@@ -12774,7 +12774,7 @@
                 </a:solidFill>
                 <a:latin typeface="Segoe UI"/>
               </a:rPr>
-              <a:t>Structured logging nativo do Spring Boot 3.4 · formato ECS</a:t>
+              <a:t>Spring Boot 3.4 em formato ECS · envio pelo agente com trace.id</a:t>
             </a:r>
           </a:p>
         </p:txBody>
@@ -12813,7 +12813,7 @@
                 </a:solidFill>
                 <a:latin typeface="Segoe UI"/>
               </a:rPr>
-              <a:t>Encaminhamento de logs pelo agente desativado: o envio é feito pelo Fluent Bit, evitando linhas duplicadas.</a:t>
+              <a:t>Logs enviados pelo agente Java com o trace.id da transação; o Fluent Bit fica desligado para evitar linhas duplicadas.</a:t>
             </a:r>
           </a:p>
         </p:txBody>

</xml_diff>

<commit_message>
docs: add environment validation to report and slides
</commit_message>
<xml_diff>
--- a/docs/tech-challenge-3/apresentacao.pptx
+++ b/docs/tech-challenge-3/apresentacao.pptx
@@ -4872,7 +4872,7 @@
                 </a:solidFill>
                 <a:latin typeface="Segoe UI"/>
               </a:rPr>
-              <a:t>A ADR-011, retroativa, identificou divergência entre o HPA (4 réplicas) e o node group (3 nós), corrigida nesta fase.</a:t>
+              <a:t>A ADR-011, retroativa, expôs divergência entre HPA e node group e previu o risco da métrica de memória; o teste de carga confirmou o risco e a ADR-015 registrou a correção.</a:t>
             </a:r>
           </a:p>
         </p:txBody>
@@ -5591,7 +5591,7 @@
                 </a:solidFill>
                 <a:latin typeface="Segoe UI"/>
               </a:rPr>
-              <a:t>145 casos de teste na aplicação e 44 na Lambda, com limite mínimo de cobertura.</a:t>
+              <a:t>147 casos de teste na aplicação e 44 na Lambda, com limite mínimo de cobertura.</a:t>
             </a:r>
           </a:p>
           <a:p>
@@ -5624,6 +5624,38 @@
                 <a:latin typeface="Segoe UI"/>
               </a:rPr>
               <a:t>Contrato OpenAPI verificado, tflint e checkov na infraestrutura.</a:t>
+            </a:r>
+          </a:p>
+          <a:p>
+            <a:pPr algn="l">
+              <a:lnSpc>
+                <a:spcPct val="125000"/>
+              </a:lnSpc>
+            </a:pPr>
+            <a:r>
+              <a:rPr sz="1200" b="0" i="0">
+                <a:solidFill>
+                  <a:srgbClr val="5A6270"/>
+                </a:solidFill>
+                <a:latin typeface="Segoe UI"/>
+              </a:rPr>
+              <a:t/>
+            </a:r>
+          </a:p>
+          <a:p>
+            <a:pPr algn="l">
+              <a:lnSpc>
+                <a:spcPct val="125000"/>
+              </a:lnSpc>
+            </a:pPr>
+            <a:r>
+              <a:rPr sz="1200" b="0" i="0">
+                <a:solidFill>
+                  <a:srgbClr val="5A6270"/>
+                </a:solidFill>
+                <a:latin typeface="Segoe UI"/>
+              </a:rPr>
+              <a:t>Ambiente validado de ponta a ponta: provisionamento, carga e destruição.</a:t>
             </a:r>
           </a:p>
         </p:txBody>

</xml_diff>